<commit_message>
Sim-Review VA05: 10 VPs umgesetzt + Artefakte neu + sim_review ✅
Co-Authored-By: Claude Fable 5 <noreply@anthropic.com>
</commit_message>
<xml_diff>
--- a/protected-downloads/praesentation/VA05.pptx
+++ b/protected-downloads/praesentation/VA05.pptx
@@ -5514,7 +5514,7 @@
                 </a:solidFill>
                 <a:latin typeface="Consolas"/>
               </a:rPr>
-              <a:t>00:50–01:05 </a:t>
+              <a:t>00:50–01:10 </a:t>
             </a:r>
             <a:r>
               <a:rPr sz="1500" b="1">
@@ -5551,7 +5551,7 @@
                 </a:solidFill>
                 <a:latin typeface="Consolas"/>
               </a:rPr>
-              <a:t>01:05–01:15 </a:t>
+              <a:t>01:10–01:18 </a:t>
             </a:r>
             <a:r>
               <a:rPr sz="1500" b="1">
@@ -5588,7 +5588,7 @@
                 </a:solidFill>
                 <a:latin typeface="Consolas"/>
               </a:rPr>
-              <a:t>01:15–01:25 </a:t>
+              <a:t>01:18–01:25 </a:t>
             </a:r>
             <a:r>
               <a:rPr sz="1500" b="1">
@@ -5597,7 +5597,7 @@
                 </a:solidFill>
                 <a:latin typeface="Arial"/>
               </a:rPr>
-              <a:t>  AB-4: Deeskalation + Reflexion</a:t>
+              <a:t>  AB-4: Deeskalation + Reflexion + Transfer-Anker</a:t>
             </a:r>
             <a:r>
               <a:rPr sz="1200">

</xml_diff>

<commit_message>
Welle 3: VA05 kuratiertes Deck + 2 Schaubilder (Web/Admin/Workbook)
Co-Authored-By: Claude Fable 5 <noreply@anthropic.com>
</commit_message>
<xml_diff>
--- a/protected-downloads/praesentation/VA05.pptx
+++ b/protected-downloads/praesentation/VA05.pptx
@@ -12,6 +12,15 @@
     <p:sldId id="260" r:id="rId12"/>
     <p:sldId id="261" r:id="rId13"/>
     <p:sldId id="262" r:id="rId14"/>
+    <p:sldId id="263" r:id="rId15"/>
+    <p:sldId id="264" r:id="rId16"/>
+    <p:sldId id="265" r:id="rId17"/>
+    <p:sldId id="266" r:id="rId18"/>
+    <p:sldId id="267" r:id="rId19"/>
+    <p:sldId id="268" r:id="rId20"/>
+    <p:sldId id="269" r:id="rId21"/>
+    <p:sldId id="270" r:id="rId22"/>
+    <p:sldId id="271" r:id="rId23"/>
   </p:sldIdLst>
   <p:sldSz cx="12188952" cy="6858000" type="screen4x3"/>
   <p:notesSz cx="6858000" cy="9144000"/>
@@ -578,7 +587,7 @@
           <a:lstStyle/>
           <a:p>
             <a:r>
-              <a:t>Siehe Trainerhandbuch (Sektion 3) für Moderationshinweise, Timing und erwartete Teilnehmerreaktionen.</a:t>
+              <a:t>Einstiegsfrage: „Was nervt Sie am meisten, wenn Sie als Kundin oder Kunde anrufen?" Antworten am Flipchart sammeln, dann am Fallbeispiel demonstrieren.</a:t>
             </a:r>
           </a:p>
         </p:txBody>
@@ -648,22 +657,7 @@
           <a:lstStyle/>
           <a:p>
             <a:r>
-              <a:t>AB-2 Musterlösung (Trainer-Version)</a:t>
-            </a:r>
-          </a:p>
-          <a:p>
-            <a:r>
-              <a:t>Guter Gesprächsverlauf: (1) Freundliche Annahme mit Bank und Namen. (2) Zuerst Verständnis: „Ich verstehe, dass Sie das Warten ärgert – das schaue ich mir sofort an." (3) Sachlage ehrlich, ohne Schuldzuweisung: „Es fehlt noch eine Unterlage; sobald die vorliegt, geht es zügig weiter." Dann konkrete Zusage: „Ich kläre das heute mit dem Berater und rufe Sie bis morgen 12 Uhr zurück." (4) Abschluss mit nächstem Schritt und Dank.</a:t>
-            </a:r>
-          </a:p>
-          <a:p>
-            <a:r>
-              <a:t>Kernbefund: Entscheidend ist die Reihenfolge – Beziehung vor Sache. Der Kunde muss sich gehört fühlen, bevor die Information ankommt. Die Zusage muss realistisch sein, sonst entsteht aus einem Ärger ein Vertrauensbruch.</a:t>
-            </a:r>
-          </a:p>
-          <a:p>
-            <a:r>
-              <a:t>Trainer-Hinweis: Lassen Sie das Telefonat als Kurz-Rollenspiel spielen (eine Person Kunde, eine Innendienst). Achten Sie darauf, ob zuerst Verständnis gezeigt oder sofort gerechtfertigt wird. Häufiger Reflex ist die Rechtfertigung – genau hier liegt der Lernpunkt. Tonfall zählt mehr als der perfekte Satz.</a:t>
+              <a:t>Die Beispielaussage des Geschäftsführers auf allen vier Seiten durchspielen. AB-1 kurz vorstellen, noch nicht ausfüllen lassen.</a:t>
             </a:r>
           </a:p>
         </p:txBody>
@@ -733,7 +727,367 @@
           <a:lstStyle/>
           <a:p>
             <a:r>
-              <a:t>Siehe Trainerhandbuch (Sektion 3) für Moderationshinweise, Timing und erwartete Teilnehmerreaktionen.</a:t>
+              <a:t>Frage an die Gruppe: „Welche dieser vier verletzen Sie am häufigsten – und warum?" Praxishinweis Auskunftspolitik/Schweigepflicht (DSGVO, Bankgeheimnis) einbetten.</a:t>
+            </a:r>
+          </a:p>
+        </p:txBody>
+      </p:sp>
+      <p:sp>
+        <p:nvSpPr>
+          <p:cNvPr id="4" name="Slide Number Placeholder 3"/>
+          <p:cNvSpPr>
+            <a:spLocks noGrp="1"/>
+          </p:cNvSpPr>
+          <p:nvPr>
+            <p:ph type="sldNum" idx="5" sz="quarter"/>
+          </p:nvPr>
+        </p:nvSpPr>
+        <p:spPr/>
+      </p:sp>
+    </p:spTree>
+  </p:cSld>
+  <p:clrMapOvr>
+    <a:masterClrMapping/>
+  </p:clrMapOvr>
+</p:notes>
+</file>
+
+<file path=ppt/notesSlides/notesSlide5.xml><?xml version="1.0" encoding="utf-8"?>
+<p:notes xmlns:a="http://schemas.openxmlformats.org/drawingml/2006/main" xmlns:p="http://schemas.openxmlformats.org/presentationml/2006/main" xmlns:r="http://schemas.openxmlformats.org/officeDocument/2006/relationships">
+  <p:cSld>
+    <p:spTree>
+      <p:nvGrpSpPr>
+        <p:cNvPr id="1" name=""/>
+        <p:cNvGrpSpPr/>
+        <p:nvPr/>
+      </p:nvGrpSpPr>
+      <p:grpSpPr>
+        <a:xfrm>
+          <a:off x="0" y="0"/>
+          <a:ext cx="0" cy="0"/>
+          <a:chOff x="0" y="0"/>
+          <a:chExt cx="0" cy="0"/>
+        </a:xfrm>
+      </p:grpSpPr>
+      <p:sp>
+        <p:nvSpPr>
+          <p:cNvPr id="2" name="Slide Image Placeholder 1"/>
+          <p:cNvSpPr>
+            <a:spLocks noGrp="1"/>
+          </p:cNvSpPr>
+          <p:nvPr>
+            <p:ph type="sldImg" idx="2"/>
+          </p:nvPr>
+        </p:nvSpPr>
+        <p:spPr/>
+      </p:sp>
+      <p:sp>
+        <p:nvSpPr>
+          <p:cNvPr id="3" name="Notes Placeholder 2"/>
+          <p:cNvSpPr>
+            <a:spLocks noGrp="1"/>
+          </p:cNvSpPr>
+          <p:nvPr>
+            <p:ph type="body" idx="3" sz="quarter"/>
+          </p:nvPr>
+        </p:nvSpPr>
+        <p:spPr/>
+        <p:txBody>
+          <a:bodyPr/>
+          <a:lstStyle/>
+          <a:p>
+            <a:r>
+              <a:t>Anruf zuerst auf den vier Seiten analysieren (AB-1), dann das Gespräch entlang der vier Schritte strukturieren (AB-2). Kurzrollenspiele mit rotierenden Rollen.</a:t>
+            </a:r>
+          </a:p>
+        </p:txBody>
+      </p:sp>
+      <p:sp>
+        <p:nvSpPr>
+          <p:cNvPr id="4" name="Slide Number Placeholder 3"/>
+          <p:cNvSpPr>
+            <a:spLocks noGrp="1"/>
+          </p:cNvSpPr>
+          <p:nvPr>
+            <p:ph type="sldNum" idx="5" sz="quarter"/>
+          </p:nvPr>
+        </p:nvSpPr>
+        <p:spPr/>
+      </p:sp>
+    </p:spTree>
+  </p:cSld>
+  <p:clrMapOvr>
+    <a:masterClrMapping/>
+  </p:clrMapOvr>
+</p:notes>
+</file>
+
+<file path=ppt/notesSlides/notesSlide6.xml><?xml version="1.0" encoding="utf-8"?>
+<p:notes xmlns:a="http://schemas.openxmlformats.org/drawingml/2006/main" xmlns:p="http://schemas.openxmlformats.org/presentationml/2006/main" xmlns:r="http://schemas.openxmlformats.org/officeDocument/2006/relationships">
+  <p:cSld>
+    <p:spTree>
+      <p:nvGrpSpPr>
+        <p:cNvPr id="1" name=""/>
+        <p:cNvGrpSpPr/>
+        <p:nvPr/>
+      </p:nvGrpSpPr>
+      <p:grpSpPr>
+        <a:xfrm>
+          <a:off x="0" y="0"/>
+          <a:ext cx="0" cy="0"/>
+          <a:chOff x="0" y="0"/>
+          <a:chExt cx="0" cy="0"/>
+        </a:xfrm>
+      </p:grpSpPr>
+      <p:sp>
+        <p:nvSpPr>
+          <p:cNvPr id="2" name="Slide Image Placeholder 1"/>
+          <p:cNvSpPr>
+            <a:spLocks noGrp="1"/>
+          </p:cNvSpPr>
+          <p:nvPr>
+            <p:ph type="sldImg" idx="2"/>
+          </p:nvPr>
+        </p:nvSpPr>
+        <p:spPr/>
+      </p:sp>
+      <p:sp>
+        <p:nvSpPr>
+          <p:cNvPr id="3" name="Notes Placeholder 2"/>
+          <p:cNvSpPr>
+            <a:spLocks noGrp="1"/>
+          </p:cNvSpPr>
+          <p:nvPr>
+            <p:ph type="body" idx="3" sz="quarter"/>
+          </p:nvPr>
+        </p:nvSpPr>
+        <p:spPr/>
+        <p:txBody>
+          <a:bodyPr/>
+          <a:lstStyle/>
+          <a:p>
+            <a:r>
+              <a:t>Empathie klingt nur aufgesetzt, wenn die Formulierung nicht der eigenen Sprache entspricht. Musterformulierungen aus AB-5 nicht wörtlich übernehmen – Prüffrage: Würden Sie den Satz auch zu einer guten Freundin sagen, die sich ärgert?</a:t>
+            </a:r>
+          </a:p>
+        </p:txBody>
+      </p:sp>
+      <p:sp>
+        <p:nvSpPr>
+          <p:cNvPr id="4" name="Slide Number Placeholder 3"/>
+          <p:cNvSpPr>
+            <a:spLocks noGrp="1"/>
+          </p:cNvSpPr>
+          <p:nvPr>
+            <p:ph type="sldNum" idx="5" sz="quarter"/>
+          </p:nvPr>
+        </p:nvSpPr>
+        <p:spPr/>
+      </p:sp>
+    </p:spTree>
+  </p:cSld>
+  <p:clrMapOvr>
+    <a:masterClrMapping/>
+  </p:clrMapOvr>
+</p:notes>
+</file>
+
+<file path=ppt/notesSlides/notesSlide7.xml><?xml version="1.0" encoding="utf-8"?>
+<p:notes xmlns:a="http://schemas.openxmlformats.org/drawingml/2006/main" xmlns:p="http://schemas.openxmlformats.org/presentationml/2006/main" xmlns:r="http://schemas.openxmlformats.org/officeDocument/2006/relationships">
+  <p:cSld>
+    <p:spTree>
+      <p:nvGrpSpPr>
+        <p:cNvPr id="1" name=""/>
+        <p:cNvGrpSpPr/>
+        <p:nvPr/>
+      </p:nvGrpSpPr>
+      <p:grpSpPr>
+        <a:xfrm>
+          <a:off x="0" y="0"/>
+          <a:ext cx="0" cy="0"/>
+          <a:chOff x="0" y="0"/>
+          <a:chExt cx="0" cy="0"/>
+        </a:xfrm>
+      </p:grpSpPr>
+      <p:sp>
+        <p:nvSpPr>
+          <p:cNvPr id="2" name="Slide Image Placeholder 1"/>
+          <p:cNvSpPr>
+            <a:spLocks noGrp="1"/>
+          </p:cNvSpPr>
+          <p:nvPr>
+            <p:ph type="sldImg" idx="2"/>
+          </p:nvPr>
+        </p:nvSpPr>
+        <p:spPr/>
+      </p:sp>
+      <p:sp>
+        <p:nvSpPr>
+          <p:cNvPr id="3" name="Notes Placeholder 2"/>
+          <p:cNvSpPr>
+            <a:spLocks noGrp="1"/>
+          </p:cNvSpPr>
+          <p:nvPr>
+            <p:ph type="body" idx="3" sz="quarter"/>
+          </p:nvPr>
+        </p:nvSpPr>
+        <p:spPr/>
+        <p:txBody>
+          <a:bodyPr/>
+          <a:lstStyle/>
+          <a:p>
+            <a:r>
+              <a:t>AB-2 Musterlösung (Trainer-Version)</a:t>
+            </a:r>
+          </a:p>
+          <a:p>
+            <a:r>
+              <a:t>Guter Ablauf: 1. Melden, 2. Ärger anerkennen und ausreden lassen, 3. Sachlage ehrlich (Unterlage fehlt), 4. konkreter Termin + Rückruf zusagen.</a:t>
+            </a:r>
+          </a:p>
+          <a:p>
+            <a:r>
+              <a:t>Trainer-Hinweis: beobachten, wann zu früh zur Sache gewechselt wird. Formulierungshemmung bei Schritt 2 als normalen Lernschritt einordnen, nicht als Defizit.</a:t>
+            </a:r>
+          </a:p>
+        </p:txBody>
+      </p:sp>
+      <p:sp>
+        <p:nvSpPr>
+          <p:cNvPr id="4" name="Slide Number Placeholder 3"/>
+          <p:cNvSpPr>
+            <a:spLocks noGrp="1"/>
+          </p:cNvSpPr>
+          <p:nvPr>
+            <p:ph type="sldNum" idx="5" sz="quarter"/>
+          </p:nvPr>
+        </p:nvSpPr>
+        <p:spPr/>
+      </p:sp>
+    </p:spTree>
+  </p:cSld>
+  <p:clrMapOvr>
+    <a:masterClrMapping/>
+  </p:clrMapOvr>
+</p:notes>
+</file>
+
+<file path=ppt/notesSlides/notesSlide8.xml><?xml version="1.0" encoding="utf-8"?>
+<p:notes xmlns:a="http://schemas.openxmlformats.org/drawingml/2006/main" xmlns:p="http://schemas.openxmlformats.org/presentationml/2006/main" xmlns:r="http://schemas.openxmlformats.org/officeDocument/2006/relationships">
+  <p:cSld>
+    <p:spTree>
+      <p:nvGrpSpPr>
+        <p:cNvPr id="1" name=""/>
+        <p:cNvGrpSpPr/>
+        <p:nvPr/>
+      </p:nvGrpSpPr>
+      <p:grpSpPr>
+        <a:xfrm>
+          <a:off x="0" y="0"/>
+          <a:ext cx="0" cy="0"/>
+          <a:chOff x="0" y="0"/>
+          <a:chExt cx="0" cy="0"/>
+        </a:xfrm>
+      </p:grpSpPr>
+      <p:sp>
+        <p:nvSpPr>
+          <p:cNvPr id="2" name="Slide Image Placeholder 1"/>
+          <p:cNvSpPr>
+            <a:spLocks noGrp="1"/>
+          </p:cNvSpPr>
+          <p:nvPr>
+            <p:ph type="sldImg" idx="2"/>
+          </p:nvPr>
+        </p:nvSpPr>
+        <p:spPr/>
+      </p:sp>
+      <p:sp>
+        <p:nvSpPr>
+          <p:cNvPr id="3" name="Notes Placeholder 2"/>
+          <p:cNvSpPr>
+            <a:spLocks noGrp="1"/>
+          </p:cNvSpPr>
+          <p:nvPr>
+            <p:ph type="body" idx="3" sz="quarter"/>
+          </p:nvPr>
+        </p:nvSpPr>
+        <p:spPr/>
+        <p:txBody>
+          <a:bodyPr/>
+          <a:lstStyle/>
+          <a:p>
+            <a:r>
+              <a:t>Transfer-Anker direkt: Sec 5.1 öffnen lassen und den ersten realen Fall sofort eintragen. Ausblick VA06 – Terminvor- und -nachbereitung.</a:t>
+            </a:r>
+          </a:p>
+        </p:txBody>
+      </p:sp>
+      <p:sp>
+        <p:nvSpPr>
+          <p:cNvPr id="4" name="Slide Number Placeholder 3"/>
+          <p:cNvSpPr>
+            <a:spLocks noGrp="1"/>
+          </p:cNvSpPr>
+          <p:nvPr>
+            <p:ph type="sldNum" idx="5" sz="quarter"/>
+          </p:nvPr>
+        </p:nvSpPr>
+        <p:spPr/>
+      </p:sp>
+    </p:spTree>
+  </p:cSld>
+  <p:clrMapOvr>
+    <a:masterClrMapping/>
+  </p:clrMapOvr>
+</p:notes>
+</file>
+
+<file path=ppt/notesSlides/notesSlide9.xml><?xml version="1.0" encoding="utf-8"?>
+<p:notes xmlns:a="http://schemas.openxmlformats.org/drawingml/2006/main" xmlns:p="http://schemas.openxmlformats.org/presentationml/2006/main" xmlns:r="http://schemas.openxmlformats.org/officeDocument/2006/relationships">
+  <p:cSld>
+    <p:spTree>
+      <p:nvGrpSpPr>
+        <p:cNvPr id="1" name=""/>
+        <p:cNvGrpSpPr/>
+        <p:nvPr/>
+      </p:nvGrpSpPr>
+      <p:grpSpPr>
+        <a:xfrm>
+          <a:off x="0" y="0"/>
+          <a:ext cx="0" cy="0"/>
+          <a:chOff x="0" y="0"/>
+          <a:chExt cx="0" cy="0"/>
+        </a:xfrm>
+      </p:grpSpPr>
+      <p:sp>
+        <p:nvSpPr>
+          <p:cNvPr id="2" name="Slide Image Placeholder 1"/>
+          <p:cNvSpPr>
+            <a:spLocks noGrp="1"/>
+          </p:cNvSpPr>
+          <p:nvPr>
+            <p:ph type="sldImg" idx="2"/>
+          </p:nvPr>
+        </p:nvSpPr>
+        <p:spPr/>
+      </p:sp>
+      <p:sp>
+        <p:nvSpPr>
+          <p:cNvPr id="3" name="Notes Placeholder 2"/>
+          <p:cNvSpPr>
+            <a:spLocks noGrp="1"/>
+          </p:cNvSpPr>
+          <p:nvPr>
+            <p:ph type="body" idx="3" sz="quarter"/>
+          </p:nvPr>
+        </p:nvSpPr>
+        <p:spPr/>
+        <p:txBody>
+          <a:bodyPr/>
+          <a:lstStyle/>
+          <a:p>
+            <a:r>
+              <a:t>Fragen 1 und 3 kurz in der Gruppe. Karte AB-5 als Schreibtisch-Werkzeug übergeben.</a:t>
             </a:r>
           </a:p>
         </p:txBody>
@@ -4304,6 +4658,2810 @@
 </p:sld>
 </file>
 
+<file path=ppt/slides/slide10.xml><?xml version="1.0" encoding="utf-8"?>
+<p:sld xmlns:a="http://schemas.openxmlformats.org/drawingml/2006/main" xmlns:p="http://schemas.openxmlformats.org/presentationml/2006/main" xmlns:r="http://schemas.openxmlformats.org/officeDocument/2006/relationships">
+  <p:cSld>
+    <p:spTree>
+      <p:nvGrpSpPr>
+        <p:cNvPr id="1" name=""/>
+        <p:cNvGrpSpPr/>
+        <p:nvPr/>
+      </p:nvGrpSpPr>
+      <p:grpSpPr/>
+      <p:sp>
+        <p:nvSpPr>
+          <p:cNvPr id="2" name="Rectangle 1"/>
+          <p:cNvSpPr/>
+          <p:nvPr/>
+        </p:nvSpPr>
+        <p:spPr>
+          <a:xfrm>
+            <a:off x="0" y="0"/>
+            <a:ext cx="12188952" cy="6858000"/>
+          </a:xfrm>
+          <a:prstGeom prst="rect">
+            <a:avLst/>
+          </a:prstGeom>
+          <a:solidFill>
+            <a:srgbClr val="FFFFFF"/>
+          </a:solidFill>
+          <a:ln>
+            <a:noFill/>
+          </a:ln>
+        </p:spPr>
+        <p:style>
+          <a:lnRef idx="1">
+            <a:schemeClr val="accent1"/>
+          </a:lnRef>
+          <a:fillRef idx="3">
+            <a:schemeClr val="accent1"/>
+          </a:fillRef>
+          <a:effectRef idx="2">
+            <a:schemeClr val="accent1"/>
+          </a:effectRef>
+          <a:fontRef idx="minor">
+            <a:schemeClr val="lt1"/>
+          </a:fontRef>
+        </p:style>
+        <p:txBody>
+          <a:bodyPr rtlCol="0" anchor="ctr"/>
+          <a:lstStyle/>
+          <a:p>
+            <a:pPr algn="ctr"/>
+          </a:p>
+        </p:txBody>
+      </p:sp>
+      <p:sp>
+        <p:nvSpPr>
+          <p:cNvPr id="3" name="Rectangle 2"/>
+          <p:cNvSpPr/>
+          <p:nvPr/>
+        </p:nvSpPr>
+        <p:spPr>
+          <a:xfrm>
+            <a:off x="0" y="0"/>
+            <a:ext cx="12188952" cy="50292"/>
+          </a:xfrm>
+          <a:prstGeom prst="rect">
+            <a:avLst/>
+          </a:prstGeom>
+          <a:solidFill>
+            <a:srgbClr val="1F2C56"/>
+          </a:solidFill>
+          <a:ln>
+            <a:noFill/>
+          </a:ln>
+        </p:spPr>
+        <p:style>
+          <a:lnRef idx="1">
+            <a:schemeClr val="accent1"/>
+          </a:lnRef>
+          <a:fillRef idx="3">
+            <a:schemeClr val="accent1"/>
+          </a:fillRef>
+          <a:effectRef idx="2">
+            <a:schemeClr val="accent1"/>
+          </a:effectRef>
+          <a:fontRef idx="minor">
+            <a:schemeClr val="lt1"/>
+          </a:fontRef>
+        </p:style>
+        <p:txBody>
+          <a:bodyPr rtlCol="0" anchor="ctr"/>
+          <a:lstStyle/>
+          <a:p>
+            <a:pPr algn="ctr"/>
+          </a:p>
+        </p:txBody>
+      </p:sp>
+      <p:sp>
+        <p:nvSpPr>
+          <p:cNvPr id="4" name="TextBox 3"/>
+          <p:cNvSpPr txBox="1"/>
+          <p:nvPr/>
+        </p:nvSpPr>
+        <p:spPr>
+          <a:xfrm>
+            <a:off x="685800" y="109728"/>
+            <a:ext cx="10817352" cy="228600"/>
+          </a:xfrm>
+          <a:prstGeom prst="rect">
+            <a:avLst/>
+          </a:prstGeom>
+          <a:noFill/>
+        </p:spPr>
+        <p:txBody>
+          <a:bodyPr wrap="none">
+            <a:spAutoFit/>
+          </a:bodyPr>
+          <a:lstStyle/>
+          <a:p>
+            <a:pPr algn="l"/>
+            <a:r>
+              <a:rPr sz="750">
+                <a:solidFill>
+                  <a:srgbClr val="78808C"/>
+                </a:solidFill>
+                <a:latin typeface="Consolas"/>
+              </a:rPr>
+              <a:t>VA05  ·  SCHAUBILD</a:t>
+            </a:r>
+          </a:p>
+        </p:txBody>
+      </p:sp>
+      <p:sp>
+        <p:nvSpPr>
+          <p:cNvPr id="5" name="TextBox 4"/>
+          <p:cNvSpPr txBox="1"/>
+          <p:nvPr/>
+        </p:nvSpPr>
+        <p:spPr>
+          <a:xfrm>
+            <a:off x="685800" y="502920"/>
+            <a:ext cx="10817352" cy="594360"/>
+          </a:xfrm>
+          <a:prstGeom prst="rect">
+            <a:avLst/>
+          </a:prstGeom>
+          <a:noFill/>
+        </p:spPr>
+        <p:txBody>
+          <a:bodyPr wrap="square">
+            <a:spAutoFit/>
+          </a:bodyPr>
+          <a:lstStyle/>
+          <a:p>
+            <a:pPr algn="l"/>
+            <a:r>
+              <a:rPr sz="2000" b="1" i="0">
+                <a:solidFill>
+                  <a:srgbClr val="1F2C56"/>
+                </a:solidFill>
+                <a:latin typeface="Arial"/>
+              </a:rPr>
+              <a:t>Das Servicetelefonat in vier Schritten</a:t>
+            </a:r>
+          </a:p>
+        </p:txBody>
+      </p:sp>
+      <p:sp>
+        <p:nvSpPr>
+          <p:cNvPr id="6" name="Rectangle 5"/>
+          <p:cNvSpPr/>
+          <p:nvPr/>
+        </p:nvSpPr>
+        <p:spPr>
+          <a:xfrm>
+            <a:off x="685800" y="1143000"/>
+            <a:ext cx="10817352" cy="25400"/>
+          </a:xfrm>
+          <a:prstGeom prst="rect">
+            <a:avLst/>
+          </a:prstGeom>
+          <a:solidFill>
+            <a:srgbClr val="D9C089"/>
+          </a:solidFill>
+          <a:ln>
+            <a:noFill/>
+          </a:ln>
+        </p:spPr>
+        <p:style>
+          <a:lnRef idx="1">
+            <a:schemeClr val="accent1"/>
+          </a:lnRef>
+          <a:fillRef idx="3">
+            <a:schemeClr val="accent1"/>
+          </a:fillRef>
+          <a:effectRef idx="2">
+            <a:schemeClr val="accent1"/>
+          </a:effectRef>
+          <a:fontRef idx="minor">
+            <a:schemeClr val="lt1"/>
+          </a:fontRef>
+        </p:style>
+        <p:txBody>
+          <a:bodyPr rtlCol="0" anchor="ctr"/>
+          <a:lstStyle/>
+          <a:p>
+            <a:pPr algn="ctr"/>
+          </a:p>
+        </p:txBody>
+      </p:sp>
+      <p:pic>
+        <p:nvPicPr>
+          <p:cNvPr id="7" name="Picture 6" descr="image.png"/>
+          <p:cNvPicPr>
+            <a:picLocks noChangeAspect="1"/>
+          </p:cNvPicPr>
+          <p:nvPr/>
+        </p:nvPicPr>
+        <p:blipFill>
+          <a:blip r:embed="rId2"/>
+          <a:stretch>
+            <a:fillRect/>
+          </a:stretch>
+        </p:blipFill>
+        <p:spPr>
+          <a:xfrm>
+            <a:off x="2009463" y="1325880"/>
+            <a:ext cx="8170026" cy="4937760"/>
+          </a:xfrm>
+          <a:prstGeom prst="rect">
+            <a:avLst/>
+          </a:prstGeom>
+        </p:spPr>
+      </p:pic>
+      <p:sp>
+        <p:nvSpPr>
+          <p:cNvPr id="8" name="Rectangle 7"/>
+          <p:cNvSpPr/>
+          <p:nvPr/>
+        </p:nvSpPr>
+        <p:spPr>
+          <a:xfrm>
+            <a:off x="0" y="6510528"/>
+            <a:ext cx="12188952" cy="347472"/>
+          </a:xfrm>
+          <a:prstGeom prst="rect">
+            <a:avLst/>
+          </a:prstGeom>
+          <a:solidFill>
+            <a:srgbClr val="0A1937"/>
+          </a:solidFill>
+          <a:ln>
+            <a:noFill/>
+          </a:ln>
+        </p:spPr>
+        <p:style>
+          <a:lnRef idx="1">
+            <a:schemeClr val="accent1"/>
+          </a:lnRef>
+          <a:fillRef idx="3">
+            <a:schemeClr val="accent1"/>
+          </a:fillRef>
+          <a:effectRef idx="2">
+            <a:schemeClr val="accent1"/>
+          </a:effectRef>
+          <a:fontRef idx="minor">
+            <a:schemeClr val="lt1"/>
+          </a:fontRef>
+        </p:style>
+        <p:txBody>
+          <a:bodyPr rtlCol="0" anchor="ctr"/>
+          <a:lstStyle/>
+          <a:p>
+            <a:pPr algn="ctr"/>
+          </a:p>
+        </p:txBody>
+      </p:sp>
+      <p:sp>
+        <p:nvSpPr>
+          <p:cNvPr id="9" name="TextBox 8"/>
+          <p:cNvSpPr txBox="1"/>
+          <p:nvPr/>
+        </p:nvSpPr>
+        <p:spPr>
+          <a:xfrm>
+            <a:off x="685800" y="6583680"/>
+            <a:ext cx="6490411" cy="256032"/>
+          </a:xfrm>
+          <a:prstGeom prst="rect">
+            <a:avLst/>
+          </a:prstGeom>
+          <a:noFill/>
+        </p:spPr>
+        <p:txBody>
+          <a:bodyPr wrap="none">
+            <a:spAutoFit/>
+          </a:bodyPr>
+          <a:lstStyle/>
+          <a:p>
+            <a:pPr algn="l"/>
+            <a:r>
+              <a:rPr sz="700">
+                <a:solidFill>
+                  <a:srgbClr val="A0B4D2"/>
+                </a:solidFill>
+                <a:latin typeface="Consolas"/>
+              </a:rPr>
+              <a:t>FKB Campus  ·  VA05</a:t>
+            </a:r>
+          </a:p>
+        </p:txBody>
+      </p:sp>
+      <p:sp>
+        <p:nvSpPr>
+          <p:cNvPr id="10" name="TextBox 9"/>
+          <p:cNvSpPr txBox="1"/>
+          <p:nvPr/>
+        </p:nvSpPr>
+        <p:spPr>
+          <a:xfrm>
+            <a:off x="7176211" y="6583680"/>
+            <a:ext cx="4326940" cy="256032"/>
+          </a:xfrm>
+          <a:prstGeom prst="rect">
+            <a:avLst/>
+          </a:prstGeom>
+          <a:noFill/>
+        </p:spPr>
+        <p:txBody>
+          <a:bodyPr wrap="none">
+            <a:spAutoFit/>
+          </a:bodyPr>
+          <a:lstStyle/>
+          <a:p>
+            <a:pPr algn="r"/>
+            <a:r>
+              <a:rPr sz="700">
+                <a:solidFill>
+                  <a:srgbClr val="A0B4D2"/>
+                </a:solidFill>
+                <a:latin typeface="Consolas"/>
+              </a:rPr>
+              <a:t>Schaubild</a:t>
+            </a:r>
+          </a:p>
+        </p:txBody>
+      </p:sp>
+    </p:spTree>
+  </p:cSld>
+  <p:clrMapOvr>
+    <a:masterClrMapping/>
+  </p:clrMapOvr>
+</p:sld>
+</file>
+
+<file path=ppt/slides/slide11.xml><?xml version="1.0" encoding="utf-8"?>
+<p:sld xmlns:a="http://schemas.openxmlformats.org/drawingml/2006/main" xmlns:p="http://schemas.openxmlformats.org/presentationml/2006/main" xmlns:r="http://schemas.openxmlformats.org/officeDocument/2006/relationships">
+  <p:cSld>
+    <p:spTree>
+      <p:nvGrpSpPr>
+        <p:cNvPr id="1" name=""/>
+        <p:cNvGrpSpPr/>
+        <p:nvPr/>
+      </p:nvGrpSpPr>
+      <p:grpSpPr/>
+      <p:sp>
+        <p:nvSpPr>
+          <p:cNvPr id="2" name="Rectangle 1"/>
+          <p:cNvSpPr/>
+          <p:nvPr/>
+        </p:nvSpPr>
+        <p:spPr>
+          <a:xfrm>
+            <a:off x="0" y="0"/>
+            <a:ext cx="12188952" cy="6858000"/>
+          </a:xfrm>
+          <a:prstGeom prst="rect">
+            <a:avLst/>
+          </a:prstGeom>
+          <a:solidFill>
+            <a:srgbClr val="1F2C56"/>
+          </a:solidFill>
+          <a:ln>
+            <a:noFill/>
+          </a:ln>
+        </p:spPr>
+        <p:style>
+          <a:lnRef idx="1">
+            <a:schemeClr val="accent1"/>
+          </a:lnRef>
+          <a:fillRef idx="3">
+            <a:schemeClr val="accent1"/>
+          </a:fillRef>
+          <a:effectRef idx="2">
+            <a:schemeClr val="accent1"/>
+          </a:effectRef>
+          <a:fontRef idx="minor">
+            <a:schemeClr val="lt1"/>
+          </a:fontRef>
+        </p:style>
+        <p:txBody>
+          <a:bodyPr rtlCol="0" anchor="ctr"/>
+          <a:lstStyle/>
+          <a:p>
+            <a:pPr algn="ctr"/>
+          </a:p>
+        </p:txBody>
+      </p:sp>
+      <p:sp>
+        <p:nvSpPr>
+          <p:cNvPr id="3" name="TextBox 2"/>
+          <p:cNvSpPr txBox="1"/>
+          <p:nvPr/>
+        </p:nvSpPr>
+        <p:spPr>
+          <a:xfrm>
+            <a:off x="685800" y="2377440"/>
+            <a:ext cx="10817352" cy="365760"/>
+          </a:xfrm>
+          <a:prstGeom prst="rect">
+            <a:avLst/>
+          </a:prstGeom>
+          <a:noFill/>
+        </p:spPr>
+        <p:txBody>
+          <a:bodyPr wrap="none">
+            <a:spAutoFit/>
+          </a:bodyPr>
+          <a:lstStyle/>
+          <a:p>
+            <a:pPr algn="l"/>
+            <a:r>
+              <a:rPr sz="1200">
+                <a:solidFill>
+                  <a:srgbClr val="D9C089"/>
+                </a:solidFill>
+                <a:latin typeface="Consolas"/>
+              </a:rPr>
+              <a:t>00:30–01:25</a:t>
+            </a:r>
+          </a:p>
+        </p:txBody>
+      </p:sp>
+      <p:sp>
+        <p:nvSpPr>
+          <p:cNvPr id="4" name="Rectangle 3"/>
+          <p:cNvSpPr/>
+          <p:nvPr/>
+        </p:nvSpPr>
+        <p:spPr>
+          <a:xfrm>
+            <a:off x="685800" y="2788920"/>
+            <a:ext cx="548640" cy="38100"/>
+          </a:xfrm>
+          <a:prstGeom prst="rect">
+            <a:avLst/>
+          </a:prstGeom>
+          <a:solidFill>
+            <a:srgbClr val="D9C089"/>
+          </a:solidFill>
+          <a:ln>
+            <a:noFill/>
+          </a:ln>
+        </p:spPr>
+        <p:style>
+          <a:lnRef idx="1">
+            <a:schemeClr val="accent1"/>
+          </a:lnRef>
+          <a:fillRef idx="3">
+            <a:schemeClr val="accent1"/>
+          </a:fillRef>
+          <a:effectRef idx="2">
+            <a:schemeClr val="accent1"/>
+          </a:effectRef>
+          <a:fontRef idx="minor">
+            <a:schemeClr val="lt1"/>
+          </a:fontRef>
+        </p:style>
+        <p:txBody>
+          <a:bodyPr rtlCol="0" anchor="ctr"/>
+          <a:lstStyle/>
+          <a:p>
+            <a:pPr algn="ctr"/>
+          </a:p>
+        </p:txBody>
+      </p:sp>
+      <p:sp>
+        <p:nvSpPr>
+          <p:cNvPr id="5" name="TextBox 4"/>
+          <p:cNvSpPr txBox="1"/>
+          <p:nvPr/>
+        </p:nvSpPr>
+        <p:spPr>
+          <a:xfrm>
+            <a:off x="685800" y="3017520"/>
+            <a:ext cx="10817352" cy="1463040"/>
+          </a:xfrm>
+          <a:prstGeom prst="rect">
+            <a:avLst/>
+          </a:prstGeom>
+          <a:noFill/>
+        </p:spPr>
+        <p:txBody>
+          <a:bodyPr wrap="square">
+            <a:spAutoFit/>
+          </a:bodyPr>
+          <a:lstStyle/>
+          <a:p>
+            <a:pPr algn="l"/>
+            <a:r>
+              <a:rPr sz="4000" b="1" i="0">
+                <a:solidFill>
+                  <a:srgbClr val="FFFFFF"/>
+                </a:solidFill>
+                <a:latin typeface="Arial"/>
+              </a:rPr>
+              <a:t>Fallübergabe &amp; Fallarbeit</a:t>
+            </a:r>
+          </a:p>
+        </p:txBody>
+      </p:sp>
+      <p:sp>
+        <p:nvSpPr>
+          <p:cNvPr id="6" name="TextBox 5"/>
+          <p:cNvSpPr txBox="1"/>
+          <p:nvPr/>
+        </p:nvSpPr>
+        <p:spPr>
+          <a:xfrm>
+            <a:off x="685800" y="4480560"/>
+            <a:ext cx="8653881" cy="1280160"/>
+          </a:xfrm>
+          <a:prstGeom prst="rect">
+            <a:avLst/>
+          </a:prstGeom>
+          <a:noFill/>
+        </p:spPr>
+        <p:txBody>
+          <a:bodyPr wrap="square">
+            <a:spAutoFit/>
+          </a:bodyPr>
+          <a:lstStyle/>
+          <a:p>
+            <a:pPr algn="l"/>
+            <a:r>
+              <a:rPr sz="1600" b="0" i="0">
+                <a:solidFill>
+                  <a:srgbClr val="C8D2E6"/>
+                </a:solidFill>
+                <a:latin typeface="Arial"/>
+              </a:rPr>
+              <a:t>Ein verärgerter Anruf und eine Mail mit drei Fragen – wie reagieren Sie?</a:t>
+            </a:r>
+          </a:p>
+        </p:txBody>
+      </p:sp>
+      <p:sp>
+        <p:nvSpPr>
+          <p:cNvPr id="7" name="TextBox 6"/>
+          <p:cNvSpPr txBox="1"/>
+          <p:nvPr/>
+        </p:nvSpPr>
+        <p:spPr>
+          <a:xfrm>
+            <a:off x="685800" y="6355080"/>
+            <a:ext cx="10817352" cy="274320"/>
+          </a:xfrm>
+          <a:prstGeom prst="rect">
+            <a:avLst/>
+          </a:prstGeom>
+          <a:noFill/>
+        </p:spPr>
+        <p:txBody>
+          <a:bodyPr wrap="none">
+            <a:spAutoFit/>
+          </a:bodyPr>
+          <a:lstStyle/>
+          <a:p>
+            <a:pPr algn="l"/>
+            <a:r>
+              <a:rPr sz="700">
+                <a:solidFill>
+                  <a:srgbClr val="8CA0C3"/>
+                </a:solidFill>
+                <a:latin typeface="Consolas"/>
+              </a:rPr>
+              <a:t>FKB Campus  ·  VA05</a:t>
+            </a:r>
+          </a:p>
+        </p:txBody>
+      </p:sp>
+    </p:spTree>
+  </p:cSld>
+  <p:clrMapOvr>
+    <a:masterClrMapping/>
+  </p:clrMapOvr>
+</p:sld>
+</file>
+
+<file path=ppt/slides/slide12.xml><?xml version="1.0" encoding="utf-8"?>
+<p:sld xmlns:a="http://schemas.openxmlformats.org/drawingml/2006/main" xmlns:p="http://schemas.openxmlformats.org/presentationml/2006/main" xmlns:r="http://schemas.openxmlformats.org/officeDocument/2006/relationships">
+  <p:cSld>
+    <p:spTree>
+      <p:nvGrpSpPr>
+        <p:cNvPr id="1" name=""/>
+        <p:cNvGrpSpPr/>
+        <p:nvPr/>
+      </p:nvGrpSpPr>
+      <p:grpSpPr/>
+      <p:sp>
+        <p:nvSpPr>
+          <p:cNvPr id="2" name="Rectangle 1"/>
+          <p:cNvSpPr/>
+          <p:nvPr/>
+        </p:nvSpPr>
+        <p:spPr>
+          <a:xfrm>
+            <a:off x="0" y="0"/>
+            <a:ext cx="12188952" cy="6858000"/>
+          </a:xfrm>
+          <a:prstGeom prst="rect">
+            <a:avLst/>
+          </a:prstGeom>
+          <a:solidFill>
+            <a:srgbClr val="EDEDF3"/>
+          </a:solidFill>
+          <a:ln>
+            <a:noFill/>
+          </a:ln>
+        </p:spPr>
+        <p:style>
+          <a:lnRef idx="1">
+            <a:schemeClr val="accent1"/>
+          </a:lnRef>
+          <a:fillRef idx="3">
+            <a:schemeClr val="accent1"/>
+          </a:fillRef>
+          <a:effectRef idx="2">
+            <a:schemeClr val="accent1"/>
+          </a:effectRef>
+          <a:fontRef idx="minor">
+            <a:schemeClr val="lt1"/>
+          </a:fontRef>
+        </p:style>
+        <p:txBody>
+          <a:bodyPr rtlCol="0" anchor="ctr"/>
+          <a:lstStyle/>
+          <a:p>
+            <a:pPr algn="ctr"/>
+          </a:p>
+        </p:txBody>
+      </p:sp>
+      <p:sp>
+        <p:nvSpPr>
+          <p:cNvPr id="3" name="Rectangle 2"/>
+          <p:cNvSpPr/>
+          <p:nvPr/>
+        </p:nvSpPr>
+        <p:spPr>
+          <a:xfrm>
+            <a:off x="0" y="0"/>
+            <a:ext cx="12188952" cy="50292"/>
+          </a:xfrm>
+          <a:prstGeom prst="rect">
+            <a:avLst/>
+          </a:prstGeom>
+          <a:solidFill>
+            <a:srgbClr val="1F2C56"/>
+          </a:solidFill>
+          <a:ln>
+            <a:noFill/>
+          </a:ln>
+        </p:spPr>
+        <p:style>
+          <a:lnRef idx="1">
+            <a:schemeClr val="accent1"/>
+          </a:lnRef>
+          <a:fillRef idx="3">
+            <a:schemeClr val="accent1"/>
+          </a:fillRef>
+          <a:effectRef idx="2">
+            <a:schemeClr val="accent1"/>
+          </a:effectRef>
+          <a:fontRef idx="minor">
+            <a:schemeClr val="lt1"/>
+          </a:fontRef>
+        </p:style>
+        <p:txBody>
+          <a:bodyPr rtlCol="0" anchor="ctr"/>
+          <a:lstStyle/>
+          <a:p>
+            <a:pPr algn="ctr"/>
+          </a:p>
+        </p:txBody>
+      </p:sp>
+      <p:sp>
+        <p:nvSpPr>
+          <p:cNvPr id="4" name="TextBox 3"/>
+          <p:cNvSpPr txBox="1"/>
+          <p:nvPr/>
+        </p:nvSpPr>
+        <p:spPr>
+          <a:xfrm>
+            <a:off x="685800" y="109728"/>
+            <a:ext cx="10817352" cy="228600"/>
+          </a:xfrm>
+          <a:prstGeom prst="rect">
+            <a:avLst/>
+          </a:prstGeom>
+          <a:noFill/>
+        </p:spPr>
+        <p:txBody>
+          <a:bodyPr wrap="none">
+            <a:spAutoFit/>
+          </a:bodyPr>
+          <a:lstStyle/>
+          <a:p>
+            <a:pPr algn="l"/>
+            <a:r>
+              <a:rPr sz="750">
+                <a:solidFill>
+                  <a:srgbClr val="78808C"/>
+                </a:solidFill>
+                <a:latin typeface="Consolas"/>
+              </a:rPr>
+              <a:t>VA05  ·  INHALT</a:t>
+            </a:r>
+          </a:p>
+        </p:txBody>
+      </p:sp>
+      <p:sp>
+        <p:nvSpPr>
+          <p:cNvPr id="5" name="Rectangle 4"/>
+          <p:cNvSpPr/>
+          <p:nvPr/>
+        </p:nvSpPr>
+        <p:spPr>
+          <a:xfrm>
+            <a:off x="0" y="1234440"/>
+            <a:ext cx="12188952" cy="12700"/>
+          </a:xfrm>
+          <a:prstGeom prst="rect">
+            <a:avLst/>
+          </a:prstGeom>
+          <a:solidFill>
+            <a:srgbClr val="D8DFE4"/>
+          </a:solidFill>
+          <a:ln>
+            <a:noFill/>
+          </a:ln>
+        </p:spPr>
+        <p:style>
+          <a:lnRef idx="1">
+            <a:schemeClr val="accent1"/>
+          </a:lnRef>
+          <a:fillRef idx="3">
+            <a:schemeClr val="accent1"/>
+          </a:fillRef>
+          <a:effectRef idx="2">
+            <a:schemeClr val="accent1"/>
+          </a:effectRef>
+          <a:fontRef idx="minor">
+            <a:schemeClr val="lt1"/>
+          </a:fontRef>
+        </p:style>
+        <p:txBody>
+          <a:bodyPr rtlCol="0" anchor="ctr"/>
+          <a:lstStyle/>
+          <a:p>
+            <a:pPr algn="ctr"/>
+          </a:p>
+        </p:txBody>
+      </p:sp>
+      <p:sp>
+        <p:nvSpPr>
+          <p:cNvPr id="6" name="Rectangle 5"/>
+          <p:cNvSpPr/>
+          <p:nvPr/>
+        </p:nvSpPr>
+        <p:spPr>
+          <a:xfrm>
+            <a:off x="685800" y="502920"/>
+            <a:ext cx="36576" cy="658368"/>
+          </a:xfrm>
+          <a:prstGeom prst="rect">
+            <a:avLst/>
+          </a:prstGeom>
+          <a:solidFill>
+            <a:srgbClr val="D9C089"/>
+          </a:solidFill>
+          <a:ln>
+            <a:noFill/>
+          </a:ln>
+        </p:spPr>
+        <p:style>
+          <a:lnRef idx="1">
+            <a:schemeClr val="accent1"/>
+          </a:lnRef>
+          <a:fillRef idx="3">
+            <a:schemeClr val="accent1"/>
+          </a:fillRef>
+          <a:effectRef idx="2">
+            <a:schemeClr val="accent1"/>
+          </a:effectRef>
+          <a:fontRef idx="minor">
+            <a:schemeClr val="lt1"/>
+          </a:fontRef>
+        </p:style>
+        <p:txBody>
+          <a:bodyPr rtlCol="0" anchor="ctr"/>
+          <a:lstStyle/>
+          <a:p>
+            <a:pPr algn="ctr"/>
+          </a:p>
+        </p:txBody>
+      </p:sp>
+      <p:sp>
+        <p:nvSpPr>
+          <p:cNvPr id="7" name="TextBox 6"/>
+          <p:cNvSpPr txBox="1"/>
+          <p:nvPr/>
+        </p:nvSpPr>
+        <p:spPr>
+          <a:xfrm>
+            <a:off x="813816" y="502920"/>
+            <a:ext cx="10634472" cy="685800"/>
+          </a:xfrm>
+          <a:prstGeom prst="rect">
+            <a:avLst/>
+          </a:prstGeom>
+          <a:noFill/>
+        </p:spPr>
+        <p:txBody>
+          <a:bodyPr wrap="square">
+            <a:spAutoFit/>
+          </a:bodyPr>
+          <a:lstStyle/>
+          <a:p>
+            <a:pPr algn="l"/>
+            <a:r>
+              <a:rPr sz="2400" b="1" i="0">
+                <a:solidFill>
+                  <a:srgbClr val="1F2C56"/>
+                </a:solidFill>
+                <a:latin typeface="Arial"/>
+              </a:rPr>
+              <a:t>Praxisfall: Ein Anruf und eine Mail</a:t>
+            </a:r>
+          </a:p>
+        </p:txBody>
+      </p:sp>
+      <p:sp>
+        <p:nvSpPr>
+          <p:cNvPr id="8" name="TextBox 7"/>
+          <p:cNvSpPr txBox="1"/>
+          <p:nvPr/>
+        </p:nvSpPr>
+        <p:spPr>
+          <a:xfrm>
+            <a:off x="685800" y="1417320"/>
+            <a:ext cx="10817352" cy="4892040"/>
+          </a:xfrm>
+          <a:prstGeom prst="rect">
+            <a:avLst/>
+          </a:prstGeom>
+          <a:noFill/>
+        </p:spPr>
+        <p:txBody>
+          <a:bodyPr wrap="square" anchor="ctr">
+            <a:spAutoFit/>
+          </a:bodyPr>
+          <a:lstStyle/>
+          <a:p>
+            <a:pPr>
+              <a:spcBef>
+                <a:spcPts val="1000"/>
+              </a:spcBef>
+              <a:spcAft>
+                <a:spcPts val="200"/>
+              </a:spcAft>
+            </a:pPr>
+            <a:r>
+              <a:rPr sz="800" b="1">
+                <a:solidFill>
+                  <a:srgbClr val="78808C"/>
+                </a:solidFill>
+                <a:latin typeface="Consolas"/>
+              </a:rPr>
+              <a:t>ZWEI VORGÄNGE, ELEKTRO MUSTERREGION GMBH</a:t>
+            </a:r>
+          </a:p>
+          <a:p>
+            <a:pPr marL="190500" indent="-190500">
+              <a:spcBef>
+                <a:spcPts val="400"/>
+              </a:spcBef>
+              <a:spcAft>
+                <a:spcPts val="200"/>
+              </a:spcAft>
+            </a:pPr>
+            <a:r>
+              <a:rPr sz="1300">
+                <a:solidFill>
+                  <a:srgbClr val="3D5466"/>
+                </a:solidFill>
+                <a:latin typeface="Arial"/>
+              </a:rPr>
+              <a:t>▸  Telefon: Der Geschäftsführer ruft verärgert an – „Ist die Darlehenszusage immer noch nicht durch? Ich warte seit über einer Woche!" Sie wissen: eine Unterlage fehlt, der Berater ist im Termin.</a:t>
+            </a:r>
+          </a:p>
+          <a:p>
+            <a:pPr marL="190500" indent="-190500">
+              <a:spcBef>
+                <a:spcPts val="400"/>
+              </a:spcBef>
+              <a:spcAft>
+                <a:spcPts val="200"/>
+              </a:spcAft>
+            </a:pPr>
+            <a:r>
+              <a:rPr sz="1300">
+                <a:solidFill>
+                  <a:srgbClr val="3D5466"/>
+                </a:solidFill>
+                <a:latin typeface="Arial"/>
+              </a:rPr>
+              <a:t>▸  Mail: Eine Mitarbeiterin schreibt drei Fragen – Stand der Zusage, benötigte Unterlagen, möglicher Auszahlungstermin.</a:t>
+            </a:r>
+          </a:p>
+          <a:p>
+            <a:pPr>
+              <a:spcBef>
+                <a:spcPts val="1000"/>
+              </a:spcBef>
+              <a:spcAft>
+                <a:spcPts val="200"/>
+              </a:spcAft>
+            </a:pPr>
+            <a:r>
+              <a:rPr sz="800" b="1">
+                <a:solidFill>
+                  <a:srgbClr val="78808C"/>
+                </a:solidFill>
+                <a:latin typeface="Consolas"/>
+              </a:rPr>
+              <a:t>IHRE AUFGABE</a:t>
+            </a:r>
+          </a:p>
+          <a:p>
+            <a:pPr marL="190500" indent="-190500">
+              <a:spcBef>
+                <a:spcPts val="400"/>
+              </a:spcBef>
+              <a:spcAft>
+                <a:spcPts val="200"/>
+              </a:spcAft>
+            </a:pPr>
+            <a:r>
+              <a:rPr sz="1300">
+                <a:solidFill>
+                  <a:srgbClr val="3D5466"/>
+                </a:solidFill>
+                <a:latin typeface="Arial"/>
+              </a:rPr>
+              <a:t>▸  Reagieren Sie auf beides: erst das Telefonat strukturieren, dann die Mail klar und serviceorientiert beantworten.</a:t>
+            </a:r>
+          </a:p>
+        </p:txBody>
+      </p:sp>
+      <p:sp>
+        <p:nvSpPr>
+          <p:cNvPr id="9" name="Rectangle 8"/>
+          <p:cNvSpPr/>
+          <p:nvPr/>
+        </p:nvSpPr>
+        <p:spPr>
+          <a:xfrm>
+            <a:off x="0" y="6510528"/>
+            <a:ext cx="12188952" cy="347472"/>
+          </a:xfrm>
+          <a:prstGeom prst="rect">
+            <a:avLst/>
+          </a:prstGeom>
+          <a:solidFill>
+            <a:srgbClr val="0A1937"/>
+          </a:solidFill>
+          <a:ln>
+            <a:noFill/>
+          </a:ln>
+        </p:spPr>
+        <p:style>
+          <a:lnRef idx="1">
+            <a:schemeClr val="accent1"/>
+          </a:lnRef>
+          <a:fillRef idx="3">
+            <a:schemeClr val="accent1"/>
+          </a:fillRef>
+          <a:effectRef idx="2">
+            <a:schemeClr val="accent1"/>
+          </a:effectRef>
+          <a:fontRef idx="minor">
+            <a:schemeClr val="lt1"/>
+          </a:fontRef>
+        </p:style>
+        <p:txBody>
+          <a:bodyPr rtlCol="0" anchor="ctr"/>
+          <a:lstStyle/>
+          <a:p>
+            <a:pPr algn="ctr"/>
+          </a:p>
+        </p:txBody>
+      </p:sp>
+      <p:sp>
+        <p:nvSpPr>
+          <p:cNvPr id="10" name="TextBox 9"/>
+          <p:cNvSpPr txBox="1"/>
+          <p:nvPr/>
+        </p:nvSpPr>
+        <p:spPr>
+          <a:xfrm>
+            <a:off x="685800" y="6583680"/>
+            <a:ext cx="6490411" cy="256032"/>
+          </a:xfrm>
+          <a:prstGeom prst="rect">
+            <a:avLst/>
+          </a:prstGeom>
+          <a:noFill/>
+        </p:spPr>
+        <p:txBody>
+          <a:bodyPr wrap="none">
+            <a:spAutoFit/>
+          </a:bodyPr>
+          <a:lstStyle/>
+          <a:p>
+            <a:pPr algn="l"/>
+            <a:r>
+              <a:rPr sz="700">
+                <a:solidFill>
+                  <a:srgbClr val="A0B4D2"/>
+                </a:solidFill>
+                <a:latin typeface="Consolas"/>
+              </a:rPr>
+              <a:t>FKB Campus  ·  VA05</a:t>
+            </a:r>
+          </a:p>
+        </p:txBody>
+      </p:sp>
+    </p:spTree>
+  </p:cSld>
+  <p:clrMapOvr>
+    <a:masterClrMapping/>
+  </p:clrMapOvr>
+</p:sld>
+</file>
+
+<file path=ppt/slides/slide13.xml><?xml version="1.0" encoding="utf-8"?>
+<p:sld xmlns:a="http://schemas.openxmlformats.org/drawingml/2006/main" xmlns:p="http://schemas.openxmlformats.org/presentationml/2006/main" xmlns:r="http://schemas.openxmlformats.org/officeDocument/2006/relationships">
+  <p:cSld>
+    <p:spTree>
+      <p:nvGrpSpPr>
+        <p:cNvPr id="1" name=""/>
+        <p:cNvGrpSpPr/>
+        <p:nvPr/>
+      </p:nvGrpSpPr>
+      <p:grpSpPr/>
+      <p:sp>
+        <p:nvSpPr>
+          <p:cNvPr id="2" name="Rectangle 1"/>
+          <p:cNvSpPr/>
+          <p:nvPr/>
+        </p:nvSpPr>
+        <p:spPr>
+          <a:xfrm>
+            <a:off x="0" y="0"/>
+            <a:ext cx="12188952" cy="6858000"/>
+          </a:xfrm>
+          <a:prstGeom prst="rect">
+            <a:avLst/>
+          </a:prstGeom>
+          <a:solidFill>
+            <a:srgbClr val="EDEDF3"/>
+          </a:solidFill>
+          <a:ln>
+            <a:noFill/>
+          </a:ln>
+        </p:spPr>
+        <p:style>
+          <a:lnRef idx="1">
+            <a:schemeClr val="accent1"/>
+          </a:lnRef>
+          <a:fillRef idx="3">
+            <a:schemeClr val="accent1"/>
+          </a:fillRef>
+          <a:effectRef idx="2">
+            <a:schemeClr val="accent1"/>
+          </a:effectRef>
+          <a:fontRef idx="minor">
+            <a:schemeClr val="lt1"/>
+          </a:fontRef>
+        </p:style>
+        <p:txBody>
+          <a:bodyPr rtlCol="0" anchor="ctr"/>
+          <a:lstStyle/>
+          <a:p>
+            <a:pPr algn="ctr"/>
+          </a:p>
+        </p:txBody>
+      </p:sp>
+      <p:sp>
+        <p:nvSpPr>
+          <p:cNvPr id="3" name="Rectangle 2"/>
+          <p:cNvSpPr/>
+          <p:nvPr/>
+        </p:nvSpPr>
+        <p:spPr>
+          <a:xfrm>
+            <a:off x="0" y="0"/>
+            <a:ext cx="12188952" cy="50292"/>
+          </a:xfrm>
+          <a:prstGeom prst="rect">
+            <a:avLst/>
+          </a:prstGeom>
+          <a:solidFill>
+            <a:srgbClr val="1F2C56"/>
+          </a:solidFill>
+          <a:ln>
+            <a:noFill/>
+          </a:ln>
+        </p:spPr>
+        <p:style>
+          <a:lnRef idx="1">
+            <a:schemeClr val="accent1"/>
+          </a:lnRef>
+          <a:fillRef idx="3">
+            <a:schemeClr val="accent1"/>
+          </a:fillRef>
+          <a:effectRef idx="2">
+            <a:schemeClr val="accent1"/>
+          </a:effectRef>
+          <a:fontRef idx="minor">
+            <a:schemeClr val="lt1"/>
+          </a:fontRef>
+        </p:style>
+        <p:txBody>
+          <a:bodyPr rtlCol="0" anchor="ctr"/>
+          <a:lstStyle/>
+          <a:p>
+            <a:pPr algn="ctr"/>
+          </a:p>
+        </p:txBody>
+      </p:sp>
+      <p:sp>
+        <p:nvSpPr>
+          <p:cNvPr id="4" name="TextBox 3"/>
+          <p:cNvSpPr txBox="1"/>
+          <p:nvPr/>
+        </p:nvSpPr>
+        <p:spPr>
+          <a:xfrm>
+            <a:off x="685800" y="109728"/>
+            <a:ext cx="10817352" cy="228600"/>
+          </a:xfrm>
+          <a:prstGeom prst="rect">
+            <a:avLst/>
+          </a:prstGeom>
+          <a:noFill/>
+        </p:spPr>
+        <p:txBody>
+          <a:bodyPr wrap="none">
+            <a:spAutoFit/>
+          </a:bodyPr>
+          <a:lstStyle/>
+          <a:p>
+            <a:pPr algn="l"/>
+            <a:r>
+              <a:rPr sz="750">
+                <a:solidFill>
+                  <a:srgbClr val="78808C"/>
+                </a:solidFill>
+                <a:latin typeface="Consolas"/>
+              </a:rPr>
+              <a:t>VA05  ·  INHALT</a:t>
+            </a:r>
+          </a:p>
+        </p:txBody>
+      </p:sp>
+      <p:sp>
+        <p:nvSpPr>
+          <p:cNvPr id="5" name="Rectangle 4"/>
+          <p:cNvSpPr/>
+          <p:nvPr/>
+        </p:nvSpPr>
+        <p:spPr>
+          <a:xfrm>
+            <a:off x="0" y="1234440"/>
+            <a:ext cx="12188952" cy="12700"/>
+          </a:xfrm>
+          <a:prstGeom prst="rect">
+            <a:avLst/>
+          </a:prstGeom>
+          <a:solidFill>
+            <a:srgbClr val="D8DFE4"/>
+          </a:solidFill>
+          <a:ln>
+            <a:noFill/>
+          </a:ln>
+        </p:spPr>
+        <p:style>
+          <a:lnRef idx="1">
+            <a:schemeClr val="accent1"/>
+          </a:lnRef>
+          <a:fillRef idx="3">
+            <a:schemeClr val="accent1"/>
+          </a:fillRef>
+          <a:effectRef idx="2">
+            <a:schemeClr val="accent1"/>
+          </a:effectRef>
+          <a:fontRef idx="minor">
+            <a:schemeClr val="lt1"/>
+          </a:fontRef>
+        </p:style>
+        <p:txBody>
+          <a:bodyPr rtlCol="0" anchor="ctr"/>
+          <a:lstStyle/>
+          <a:p>
+            <a:pPr algn="ctr"/>
+          </a:p>
+        </p:txBody>
+      </p:sp>
+      <p:sp>
+        <p:nvSpPr>
+          <p:cNvPr id="6" name="Rectangle 5"/>
+          <p:cNvSpPr/>
+          <p:nvPr/>
+        </p:nvSpPr>
+        <p:spPr>
+          <a:xfrm>
+            <a:off x="685800" y="502920"/>
+            <a:ext cx="36576" cy="658368"/>
+          </a:xfrm>
+          <a:prstGeom prst="rect">
+            <a:avLst/>
+          </a:prstGeom>
+          <a:solidFill>
+            <a:srgbClr val="D9C089"/>
+          </a:solidFill>
+          <a:ln>
+            <a:noFill/>
+          </a:ln>
+        </p:spPr>
+        <p:style>
+          <a:lnRef idx="1">
+            <a:schemeClr val="accent1"/>
+          </a:lnRef>
+          <a:fillRef idx="3">
+            <a:schemeClr val="accent1"/>
+          </a:fillRef>
+          <a:effectRef idx="2">
+            <a:schemeClr val="accent1"/>
+          </a:effectRef>
+          <a:fontRef idx="minor">
+            <a:schemeClr val="lt1"/>
+          </a:fontRef>
+        </p:style>
+        <p:txBody>
+          <a:bodyPr rtlCol="0" anchor="ctr"/>
+          <a:lstStyle/>
+          <a:p>
+            <a:pPr algn="ctr"/>
+          </a:p>
+        </p:txBody>
+      </p:sp>
+      <p:sp>
+        <p:nvSpPr>
+          <p:cNvPr id="7" name="TextBox 6"/>
+          <p:cNvSpPr txBox="1"/>
+          <p:nvPr/>
+        </p:nvSpPr>
+        <p:spPr>
+          <a:xfrm>
+            <a:off x="813816" y="502920"/>
+            <a:ext cx="10634472" cy="685800"/>
+          </a:xfrm>
+          <a:prstGeom prst="rect">
+            <a:avLst/>
+          </a:prstGeom>
+          <a:noFill/>
+        </p:spPr>
+        <p:txBody>
+          <a:bodyPr wrap="square">
+            <a:spAutoFit/>
+          </a:bodyPr>
+          <a:lstStyle/>
+          <a:p>
+            <a:pPr algn="l"/>
+            <a:r>
+              <a:rPr sz="2400" b="1" i="0">
+                <a:solidFill>
+                  <a:srgbClr val="1F2C56"/>
+                </a:solidFill>
+                <a:latin typeface="Arial"/>
+              </a:rPr>
+              <a:t>Handlungsempfehlung: Beziehung vor Sache</a:t>
+            </a:r>
+          </a:p>
+        </p:txBody>
+      </p:sp>
+      <p:sp>
+        <p:nvSpPr>
+          <p:cNvPr id="8" name="TextBox 7"/>
+          <p:cNvSpPr txBox="1"/>
+          <p:nvPr/>
+        </p:nvSpPr>
+        <p:spPr>
+          <a:xfrm>
+            <a:off x="685800" y="1417320"/>
+            <a:ext cx="10817352" cy="4892040"/>
+          </a:xfrm>
+          <a:prstGeom prst="rect">
+            <a:avLst/>
+          </a:prstGeom>
+          <a:noFill/>
+        </p:spPr>
+        <p:txBody>
+          <a:bodyPr wrap="square" anchor="ctr">
+            <a:spAutoFit/>
+          </a:bodyPr>
+          <a:lstStyle/>
+          <a:p>
+            <a:pPr marL="177800" indent="-177800">
+              <a:spcBef>
+                <a:spcPts val="600"/>
+              </a:spcBef>
+              <a:spcAft>
+                <a:spcPts val="200"/>
+              </a:spcAft>
+            </a:pPr>
+            <a:r>
+              <a:rPr sz="1200" i="1">
+                <a:solidFill>
+                  <a:srgbClr val="3D5466"/>
+                </a:solidFill>
+                <a:latin typeface="Arial"/>
+              </a:rPr>
+              <a:t>→  Wenn ein Kunde verärgert anruft — dann zuerst zuhören und Verständnis zeigen, erst danach die Sachlage erklären (Beziehung vor Sache).</a:t>
+            </a:r>
+          </a:p>
+          <a:p>
+            <a:pPr marL="177800" indent="-177800">
+              <a:spcBef>
+                <a:spcPts val="600"/>
+              </a:spcBef>
+              <a:spcAft>
+                <a:spcPts val="200"/>
+              </a:spcAft>
+            </a:pPr>
+            <a:r>
+              <a:rPr sz="1200" i="1">
+                <a:solidFill>
+                  <a:srgbClr val="3D5466"/>
+                </a:solidFill>
+                <a:latin typeface="Arial"/>
+              </a:rPr>
+              <a:t>→  Wenn eine offene Zusage im Raum steht — dann proaktiv einen realistischen Termin und den nächsten Schritt nennen (Zuverlässigkeit).</a:t>
+            </a:r>
+          </a:p>
+          <a:p>
+            <a:pPr marL="177800" indent="-177800">
+              <a:spcBef>
+                <a:spcPts val="600"/>
+              </a:spcBef>
+              <a:spcAft>
+                <a:spcPts val="200"/>
+              </a:spcAft>
+            </a:pPr>
+            <a:r>
+              <a:rPr sz="1200" i="1">
+                <a:solidFill>
+                  <a:srgbClr val="3D5466"/>
+                </a:solidFill>
+                <a:latin typeface="Arial"/>
+              </a:rPr>
+              <a:t>→  Wenn eine Mail mehrere Fragen enthält — dann jede Frage sichtbar einzeln beantworten, in der Reihenfolge der Mail.</a:t>
+            </a:r>
+          </a:p>
+        </p:txBody>
+      </p:sp>
+      <p:sp>
+        <p:nvSpPr>
+          <p:cNvPr id="9" name="Rectangle 8"/>
+          <p:cNvSpPr/>
+          <p:nvPr/>
+        </p:nvSpPr>
+        <p:spPr>
+          <a:xfrm>
+            <a:off x="0" y="6510528"/>
+            <a:ext cx="12188952" cy="347472"/>
+          </a:xfrm>
+          <a:prstGeom prst="rect">
+            <a:avLst/>
+          </a:prstGeom>
+          <a:solidFill>
+            <a:srgbClr val="0A1937"/>
+          </a:solidFill>
+          <a:ln>
+            <a:noFill/>
+          </a:ln>
+        </p:spPr>
+        <p:style>
+          <a:lnRef idx="1">
+            <a:schemeClr val="accent1"/>
+          </a:lnRef>
+          <a:fillRef idx="3">
+            <a:schemeClr val="accent1"/>
+          </a:fillRef>
+          <a:effectRef idx="2">
+            <a:schemeClr val="accent1"/>
+          </a:effectRef>
+          <a:fontRef idx="minor">
+            <a:schemeClr val="lt1"/>
+          </a:fontRef>
+        </p:style>
+        <p:txBody>
+          <a:bodyPr rtlCol="0" anchor="ctr"/>
+          <a:lstStyle/>
+          <a:p>
+            <a:pPr algn="ctr"/>
+          </a:p>
+        </p:txBody>
+      </p:sp>
+      <p:sp>
+        <p:nvSpPr>
+          <p:cNvPr id="10" name="TextBox 9"/>
+          <p:cNvSpPr txBox="1"/>
+          <p:nvPr/>
+        </p:nvSpPr>
+        <p:spPr>
+          <a:xfrm>
+            <a:off x="685800" y="6583680"/>
+            <a:ext cx="6490411" cy="256032"/>
+          </a:xfrm>
+          <a:prstGeom prst="rect">
+            <a:avLst/>
+          </a:prstGeom>
+          <a:noFill/>
+        </p:spPr>
+        <p:txBody>
+          <a:bodyPr wrap="none">
+            <a:spAutoFit/>
+          </a:bodyPr>
+          <a:lstStyle/>
+          <a:p>
+            <a:pPr algn="l"/>
+            <a:r>
+              <a:rPr sz="700">
+                <a:solidFill>
+                  <a:srgbClr val="A0B4D2"/>
+                </a:solidFill>
+                <a:latin typeface="Consolas"/>
+              </a:rPr>
+              <a:t>FKB Campus  ·  VA05</a:t>
+            </a:r>
+          </a:p>
+        </p:txBody>
+      </p:sp>
+    </p:spTree>
+  </p:cSld>
+  <p:clrMapOvr>
+    <a:masterClrMapping/>
+  </p:clrMapOvr>
+</p:sld>
+</file>
+
+<file path=ppt/slides/slide14.xml><?xml version="1.0" encoding="utf-8"?>
+<p:sld xmlns:a="http://schemas.openxmlformats.org/drawingml/2006/main" xmlns:p="http://schemas.openxmlformats.org/presentationml/2006/main" xmlns:r="http://schemas.openxmlformats.org/officeDocument/2006/relationships">
+  <p:cSld>
+    <p:spTree>
+      <p:nvGrpSpPr>
+        <p:cNvPr id="1" name=""/>
+        <p:cNvGrpSpPr/>
+        <p:nvPr/>
+      </p:nvGrpSpPr>
+      <p:grpSpPr/>
+      <p:sp>
+        <p:nvSpPr>
+          <p:cNvPr id="2" name="Rectangle 1"/>
+          <p:cNvSpPr/>
+          <p:nvPr/>
+        </p:nvSpPr>
+        <p:spPr>
+          <a:xfrm>
+            <a:off x="0" y="0"/>
+            <a:ext cx="12188952" cy="6858000"/>
+          </a:xfrm>
+          <a:prstGeom prst="rect">
+            <a:avLst/>
+          </a:prstGeom>
+          <a:solidFill>
+            <a:srgbClr val="EDEDF3"/>
+          </a:solidFill>
+          <a:ln>
+            <a:noFill/>
+          </a:ln>
+        </p:spPr>
+        <p:style>
+          <a:lnRef idx="1">
+            <a:schemeClr val="accent1"/>
+          </a:lnRef>
+          <a:fillRef idx="3">
+            <a:schemeClr val="accent1"/>
+          </a:fillRef>
+          <a:effectRef idx="2">
+            <a:schemeClr val="accent1"/>
+          </a:effectRef>
+          <a:fontRef idx="minor">
+            <a:schemeClr val="lt1"/>
+          </a:fontRef>
+        </p:style>
+        <p:txBody>
+          <a:bodyPr rtlCol="0" anchor="ctr"/>
+          <a:lstStyle/>
+          <a:p>
+            <a:pPr algn="ctr"/>
+          </a:p>
+        </p:txBody>
+      </p:sp>
+      <p:sp>
+        <p:nvSpPr>
+          <p:cNvPr id="3" name="Rectangle 2"/>
+          <p:cNvSpPr/>
+          <p:nvPr/>
+        </p:nvSpPr>
+        <p:spPr>
+          <a:xfrm>
+            <a:off x="0" y="0"/>
+            <a:ext cx="12188952" cy="50292"/>
+          </a:xfrm>
+          <a:prstGeom prst="rect">
+            <a:avLst/>
+          </a:prstGeom>
+          <a:solidFill>
+            <a:srgbClr val="1F2C56"/>
+          </a:solidFill>
+          <a:ln>
+            <a:noFill/>
+          </a:ln>
+        </p:spPr>
+        <p:style>
+          <a:lnRef idx="1">
+            <a:schemeClr val="accent1"/>
+          </a:lnRef>
+          <a:fillRef idx="3">
+            <a:schemeClr val="accent1"/>
+          </a:fillRef>
+          <a:effectRef idx="2">
+            <a:schemeClr val="accent1"/>
+          </a:effectRef>
+          <a:fontRef idx="minor">
+            <a:schemeClr val="lt1"/>
+          </a:fontRef>
+        </p:style>
+        <p:txBody>
+          <a:bodyPr rtlCol="0" anchor="ctr"/>
+          <a:lstStyle/>
+          <a:p>
+            <a:pPr algn="ctr"/>
+          </a:p>
+        </p:txBody>
+      </p:sp>
+      <p:sp>
+        <p:nvSpPr>
+          <p:cNvPr id="4" name="TextBox 3"/>
+          <p:cNvSpPr txBox="1"/>
+          <p:nvPr/>
+        </p:nvSpPr>
+        <p:spPr>
+          <a:xfrm>
+            <a:off x="685800" y="109728"/>
+            <a:ext cx="10817352" cy="228600"/>
+          </a:xfrm>
+          <a:prstGeom prst="rect">
+            <a:avLst/>
+          </a:prstGeom>
+          <a:noFill/>
+        </p:spPr>
+        <p:txBody>
+          <a:bodyPr wrap="none">
+            <a:spAutoFit/>
+          </a:bodyPr>
+          <a:lstStyle/>
+          <a:p>
+            <a:pPr algn="l"/>
+            <a:r>
+              <a:rPr sz="750">
+                <a:solidFill>
+                  <a:srgbClr val="78808C"/>
+                </a:solidFill>
+                <a:latin typeface="Consolas"/>
+              </a:rPr>
+              <a:t>VA05  ·  ARBEITSBLATT</a:t>
+            </a:r>
+          </a:p>
+        </p:txBody>
+      </p:sp>
+      <p:sp>
+        <p:nvSpPr>
+          <p:cNvPr id="5" name="Rectangle 4"/>
+          <p:cNvSpPr/>
+          <p:nvPr/>
+        </p:nvSpPr>
+        <p:spPr>
+          <a:xfrm>
+            <a:off x="0" y="1234440"/>
+            <a:ext cx="12188952" cy="12700"/>
+          </a:xfrm>
+          <a:prstGeom prst="rect">
+            <a:avLst/>
+          </a:prstGeom>
+          <a:solidFill>
+            <a:srgbClr val="D8DFE4"/>
+          </a:solidFill>
+          <a:ln>
+            <a:noFill/>
+          </a:ln>
+        </p:spPr>
+        <p:style>
+          <a:lnRef idx="1">
+            <a:schemeClr val="accent1"/>
+          </a:lnRef>
+          <a:fillRef idx="3">
+            <a:schemeClr val="accent1"/>
+          </a:fillRef>
+          <a:effectRef idx="2">
+            <a:schemeClr val="accent1"/>
+          </a:effectRef>
+          <a:fontRef idx="minor">
+            <a:schemeClr val="lt1"/>
+          </a:fontRef>
+        </p:style>
+        <p:txBody>
+          <a:bodyPr rtlCol="0" anchor="ctr"/>
+          <a:lstStyle/>
+          <a:p>
+            <a:pPr algn="ctr"/>
+          </a:p>
+        </p:txBody>
+      </p:sp>
+      <p:sp>
+        <p:nvSpPr>
+          <p:cNvPr id="6" name="Rectangle 5"/>
+          <p:cNvSpPr/>
+          <p:nvPr/>
+        </p:nvSpPr>
+        <p:spPr>
+          <a:xfrm>
+            <a:off x="685800" y="502920"/>
+            <a:ext cx="36576" cy="658368"/>
+          </a:xfrm>
+          <a:prstGeom prst="rect">
+            <a:avLst/>
+          </a:prstGeom>
+          <a:solidFill>
+            <a:srgbClr val="D9C089"/>
+          </a:solidFill>
+          <a:ln>
+            <a:noFill/>
+          </a:ln>
+        </p:spPr>
+        <p:style>
+          <a:lnRef idx="1">
+            <a:schemeClr val="accent1"/>
+          </a:lnRef>
+          <a:fillRef idx="3">
+            <a:schemeClr val="accent1"/>
+          </a:fillRef>
+          <a:effectRef idx="2">
+            <a:schemeClr val="accent1"/>
+          </a:effectRef>
+          <a:fontRef idx="minor">
+            <a:schemeClr val="lt1"/>
+          </a:fontRef>
+        </p:style>
+        <p:txBody>
+          <a:bodyPr rtlCol="0" anchor="ctr"/>
+          <a:lstStyle/>
+          <a:p>
+            <a:pPr algn="ctr"/>
+          </a:p>
+        </p:txBody>
+      </p:sp>
+      <p:sp>
+        <p:nvSpPr>
+          <p:cNvPr id="7" name="TextBox 6"/>
+          <p:cNvSpPr txBox="1"/>
+          <p:nvPr/>
+        </p:nvSpPr>
+        <p:spPr>
+          <a:xfrm>
+            <a:off x="813816" y="502920"/>
+            <a:ext cx="10634472" cy="685800"/>
+          </a:xfrm>
+          <a:prstGeom prst="rect">
+            <a:avLst/>
+          </a:prstGeom>
+          <a:noFill/>
+        </p:spPr>
+        <p:txBody>
+          <a:bodyPr wrap="square">
+            <a:spAutoFit/>
+          </a:bodyPr>
+          <a:lstStyle/>
+          <a:p>
+            <a:pPr algn="l"/>
+            <a:r>
+              <a:rPr sz="2400" b="1" i="0">
+                <a:solidFill>
+                  <a:srgbClr val="1F2C56"/>
+                </a:solidFill>
+                <a:latin typeface="Arial"/>
+              </a:rPr>
+              <a:t>Praxisfall bearbeiten: Telefonat und Mail</a:t>
+            </a:r>
+          </a:p>
+        </p:txBody>
+      </p:sp>
+      <p:sp>
+        <p:nvSpPr>
+          <p:cNvPr id="8" name="TextBox 7"/>
+          <p:cNvSpPr txBox="1"/>
+          <p:nvPr/>
+        </p:nvSpPr>
+        <p:spPr>
+          <a:xfrm>
+            <a:off x="685800" y="1554480"/>
+            <a:ext cx="10817352" cy="3840480"/>
+          </a:xfrm>
+          <a:prstGeom prst="rect">
+            <a:avLst/>
+          </a:prstGeom>
+          <a:noFill/>
+        </p:spPr>
+        <p:txBody>
+          <a:bodyPr wrap="square">
+            <a:spAutoFit/>
+          </a:bodyPr>
+          <a:lstStyle/>
+          <a:p>
+            <a:pPr marL="190500" indent="-190500">
+              <a:spcBef>
+                <a:spcPts val="400"/>
+              </a:spcBef>
+              <a:spcAft>
+                <a:spcPts val="200"/>
+              </a:spcAft>
+            </a:pPr>
+            <a:r>
+              <a:rPr sz="1400">
+                <a:solidFill>
+                  <a:srgbClr val="3D5466"/>
+                </a:solidFill>
+                <a:latin typeface="Arial"/>
+              </a:rPr>
+              <a:t>▸  Analysieren Sie die Aussage des Geschäftsführers auf den vier Seiten (AB-1).</a:t>
+            </a:r>
+          </a:p>
+          <a:p>
+            <a:pPr marL="190500" indent="-190500">
+              <a:spcBef>
+                <a:spcPts val="400"/>
+              </a:spcBef>
+              <a:spcAft>
+                <a:spcPts val="200"/>
+              </a:spcAft>
+            </a:pPr>
+            <a:r>
+              <a:rPr sz="1400">
+                <a:solidFill>
+                  <a:srgbClr val="3D5466"/>
+                </a:solidFill>
+                <a:latin typeface="Arial"/>
+              </a:rPr>
+              <a:t>▸  Strukturieren Sie das Telefonat entlang der vier Schritte und spielen Sie es im Paar (AB-2).</a:t>
+            </a:r>
+          </a:p>
+          <a:p>
+            <a:pPr marL="190500" indent="-190500">
+              <a:spcBef>
+                <a:spcPts val="400"/>
+              </a:spcBef>
+              <a:spcAft>
+                <a:spcPts val="200"/>
+              </a:spcAft>
+            </a:pPr>
+            <a:r>
+              <a:rPr sz="1400">
+                <a:solidFill>
+                  <a:srgbClr val="3D5466"/>
+                </a:solidFill>
+                <a:latin typeface="Arial"/>
+              </a:rPr>
+              <a:t>▸  Formulieren Sie die Antwortmail an die Mitarbeiterin – klar, freundlich, vollständig (AB-3).</a:t>
+            </a:r>
+          </a:p>
+          <a:p>
+            <a:pPr marL="190500" indent="-190500">
+              <a:spcBef>
+                <a:spcPts val="400"/>
+              </a:spcBef>
+              <a:spcAft>
+                <a:spcPts val="200"/>
+              </a:spcAft>
+            </a:pPr>
+            <a:r>
+              <a:rPr sz="1400">
+                <a:solidFill>
+                  <a:srgbClr val="3D5466"/>
+                </a:solidFill>
+                <a:latin typeface="Arial"/>
+              </a:rPr>
+              <a:t>▸  Finden Sie den ersten deeskalierenden Satz für ein zweites Szenario (AB-4) – Karte AB-5 als Werkzeug.</a:t>
+            </a:r>
+          </a:p>
+        </p:txBody>
+      </p:sp>
+      <p:sp>
+        <p:nvSpPr>
+          <p:cNvPr id="9" name="Rectangle 8"/>
+          <p:cNvSpPr/>
+          <p:nvPr/>
+        </p:nvSpPr>
+        <p:spPr>
+          <a:xfrm>
+            <a:off x="685800" y="5486400"/>
+            <a:ext cx="10817352" cy="640080"/>
+          </a:xfrm>
+          <a:prstGeom prst="rect">
+            <a:avLst/>
+          </a:prstGeom>
+          <a:solidFill>
+            <a:srgbClr val="1F2C56"/>
+          </a:solidFill>
+          <a:ln>
+            <a:noFill/>
+          </a:ln>
+        </p:spPr>
+        <p:style>
+          <a:lnRef idx="1">
+            <a:schemeClr val="accent1"/>
+          </a:lnRef>
+          <a:fillRef idx="3">
+            <a:schemeClr val="accent1"/>
+          </a:fillRef>
+          <a:effectRef idx="2">
+            <a:schemeClr val="accent1"/>
+          </a:effectRef>
+          <a:fontRef idx="minor">
+            <a:schemeClr val="lt1"/>
+          </a:fontRef>
+        </p:style>
+        <p:txBody>
+          <a:bodyPr rtlCol="0" anchor="ctr"/>
+          <a:lstStyle/>
+          <a:p>
+            <a:pPr algn="ctr"/>
+          </a:p>
+        </p:txBody>
+      </p:sp>
+      <p:sp>
+        <p:nvSpPr>
+          <p:cNvPr id="10" name="TextBox 9"/>
+          <p:cNvSpPr txBox="1"/>
+          <p:nvPr/>
+        </p:nvSpPr>
+        <p:spPr>
+          <a:xfrm>
+            <a:off x="868680" y="5596128"/>
+            <a:ext cx="10451592" cy="457200"/>
+          </a:xfrm>
+          <a:prstGeom prst="rect">
+            <a:avLst/>
+          </a:prstGeom>
+          <a:noFill/>
+        </p:spPr>
+        <p:txBody>
+          <a:bodyPr wrap="square">
+            <a:spAutoFit/>
+          </a:bodyPr>
+          <a:lstStyle/>
+          <a:p>
+            <a:pPr algn="l"/>
+            <a:r>
+              <a:rPr sz="1300" b="1" i="0">
+                <a:solidFill>
+                  <a:srgbClr val="FFFFFF"/>
+                </a:solidFill>
+                <a:latin typeface="Arial"/>
+              </a:rPr>
+              <a:t>→  Bearbeitung im Teilnehmer-Workbook (Arbeitsblatt mit Ausfüllfeldern)</a:t>
+            </a:r>
+          </a:p>
+        </p:txBody>
+      </p:sp>
+      <p:sp>
+        <p:nvSpPr>
+          <p:cNvPr id="11" name="Rectangle 10"/>
+          <p:cNvSpPr/>
+          <p:nvPr/>
+        </p:nvSpPr>
+        <p:spPr>
+          <a:xfrm>
+            <a:off x="0" y="6510528"/>
+            <a:ext cx="12188952" cy="347472"/>
+          </a:xfrm>
+          <a:prstGeom prst="rect">
+            <a:avLst/>
+          </a:prstGeom>
+          <a:solidFill>
+            <a:srgbClr val="0A1937"/>
+          </a:solidFill>
+          <a:ln>
+            <a:noFill/>
+          </a:ln>
+        </p:spPr>
+        <p:style>
+          <a:lnRef idx="1">
+            <a:schemeClr val="accent1"/>
+          </a:lnRef>
+          <a:fillRef idx="3">
+            <a:schemeClr val="accent1"/>
+          </a:fillRef>
+          <a:effectRef idx="2">
+            <a:schemeClr val="accent1"/>
+          </a:effectRef>
+          <a:fontRef idx="minor">
+            <a:schemeClr val="lt1"/>
+          </a:fontRef>
+        </p:style>
+        <p:txBody>
+          <a:bodyPr rtlCol="0" anchor="ctr"/>
+          <a:lstStyle/>
+          <a:p>
+            <a:pPr algn="ctr"/>
+          </a:p>
+        </p:txBody>
+      </p:sp>
+      <p:sp>
+        <p:nvSpPr>
+          <p:cNvPr id="12" name="TextBox 11"/>
+          <p:cNvSpPr txBox="1"/>
+          <p:nvPr/>
+        </p:nvSpPr>
+        <p:spPr>
+          <a:xfrm>
+            <a:off x="685800" y="6583680"/>
+            <a:ext cx="6490411" cy="256032"/>
+          </a:xfrm>
+          <a:prstGeom prst="rect">
+            <a:avLst/>
+          </a:prstGeom>
+          <a:noFill/>
+        </p:spPr>
+        <p:txBody>
+          <a:bodyPr wrap="none">
+            <a:spAutoFit/>
+          </a:bodyPr>
+          <a:lstStyle/>
+          <a:p>
+            <a:pPr algn="l"/>
+            <a:r>
+              <a:rPr sz="700">
+                <a:solidFill>
+                  <a:srgbClr val="A0B4D2"/>
+                </a:solidFill>
+                <a:latin typeface="Consolas"/>
+              </a:rPr>
+              <a:t>FKB Campus  ·  VA05</a:t>
+            </a:r>
+          </a:p>
+        </p:txBody>
+      </p:sp>
+    </p:spTree>
+  </p:cSld>
+  <p:clrMapOvr>
+    <a:masterClrMapping/>
+  </p:clrMapOvr>
+</p:sld>
+</file>
+
+<file path=ppt/slides/slide15.xml><?xml version="1.0" encoding="utf-8"?>
+<p:sld xmlns:a="http://schemas.openxmlformats.org/drawingml/2006/main" xmlns:p="http://schemas.openxmlformats.org/presentationml/2006/main" xmlns:r="http://schemas.openxmlformats.org/officeDocument/2006/relationships">
+  <p:cSld>
+    <p:spTree>
+      <p:nvGrpSpPr>
+        <p:cNvPr id="1" name=""/>
+        <p:cNvGrpSpPr/>
+        <p:nvPr/>
+      </p:nvGrpSpPr>
+      <p:grpSpPr/>
+      <p:sp>
+        <p:nvSpPr>
+          <p:cNvPr id="2" name="Rectangle 1"/>
+          <p:cNvSpPr/>
+          <p:nvPr/>
+        </p:nvSpPr>
+        <p:spPr>
+          <a:xfrm>
+            <a:off x="0" y="0"/>
+            <a:ext cx="12188952" cy="6858000"/>
+          </a:xfrm>
+          <a:prstGeom prst="rect">
+            <a:avLst/>
+          </a:prstGeom>
+          <a:solidFill>
+            <a:srgbClr val="EDEDF3"/>
+          </a:solidFill>
+          <a:ln>
+            <a:noFill/>
+          </a:ln>
+        </p:spPr>
+        <p:style>
+          <a:lnRef idx="1">
+            <a:schemeClr val="accent1"/>
+          </a:lnRef>
+          <a:fillRef idx="3">
+            <a:schemeClr val="accent1"/>
+          </a:fillRef>
+          <a:effectRef idx="2">
+            <a:schemeClr val="accent1"/>
+          </a:effectRef>
+          <a:fontRef idx="minor">
+            <a:schemeClr val="lt1"/>
+          </a:fontRef>
+        </p:style>
+        <p:txBody>
+          <a:bodyPr rtlCol="0" anchor="ctr"/>
+          <a:lstStyle/>
+          <a:p>
+            <a:pPr algn="ctr"/>
+          </a:p>
+        </p:txBody>
+      </p:sp>
+      <p:sp>
+        <p:nvSpPr>
+          <p:cNvPr id="3" name="Rectangle 2"/>
+          <p:cNvSpPr/>
+          <p:nvPr/>
+        </p:nvSpPr>
+        <p:spPr>
+          <a:xfrm>
+            <a:off x="0" y="0"/>
+            <a:ext cx="12188952" cy="50292"/>
+          </a:xfrm>
+          <a:prstGeom prst="rect">
+            <a:avLst/>
+          </a:prstGeom>
+          <a:solidFill>
+            <a:srgbClr val="1F2C56"/>
+          </a:solidFill>
+          <a:ln>
+            <a:noFill/>
+          </a:ln>
+        </p:spPr>
+        <p:style>
+          <a:lnRef idx="1">
+            <a:schemeClr val="accent1"/>
+          </a:lnRef>
+          <a:fillRef idx="3">
+            <a:schemeClr val="accent1"/>
+          </a:fillRef>
+          <a:effectRef idx="2">
+            <a:schemeClr val="accent1"/>
+          </a:effectRef>
+          <a:fontRef idx="minor">
+            <a:schemeClr val="lt1"/>
+          </a:fontRef>
+        </p:style>
+        <p:txBody>
+          <a:bodyPr rtlCol="0" anchor="ctr"/>
+          <a:lstStyle/>
+          <a:p>
+            <a:pPr algn="ctr"/>
+          </a:p>
+        </p:txBody>
+      </p:sp>
+      <p:sp>
+        <p:nvSpPr>
+          <p:cNvPr id="4" name="TextBox 3"/>
+          <p:cNvSpPr txBox="1"/>
+          <p:nvPr/>
+        </p:nvSpPr>
+        <p:spPr>
+          <a:xfrm>
+            <a:off x="685800" y="109728"/>
+            <a:ext cx="10817352" cy="228600"/>
+          </a:xfrm>
+          <a:prstGeom prst="rect">
+            <a:avLst/>
+          </a:prstGeom>
+          <a:noFill/>
+        </p:spPr>
+        <p:txBody>
+          <a:bodyPr wrap="none">
+            <a:spAutoFit/>
+          </a:bodyPr>
+          <a:lstStyle/>
+          <a:p>
+            <a:pPr algn="l"/>
+            <a:r>
+              <a:rPr sz="750">
+                <a:solidFill>
+                  <a:srgbClr val="78808C"/>
+                </a:solidFill>
+                <a:latin typeface="Consolas"/>
+              </a:rPr>
+              <a:t>VA05  ·  INHALT</a:t>
+            </a:r>
+          </a:p>
+        </p:txBody>
+      </p:sp>
+      <p:sp>
+        <p:nvSpPr>
+          <p:cNvPr id="5" name="Rectangle 4"/>
+          <p:cNvSpPr/>
+          <p:nvPr/>
+        </p:nvSpPr>
+        <p:spPr>
+          <a:xfrm>
+            <a:off x="0" y="1234440"/>
+            <a:ext cx="12188952" cy="12700"/>
+          </a:xfrm>
+          <a:prstGeom prst="rect">
+            <a:avLst/>
+          </a:prstGeom>
+          <a:solidFill>
+            <a:srgbClr val="D8DFE4"/>
+          </a:solidFill>
+          <a:ln>
+            <a:noFill/>
+          </a:ln>
+        </p:spPr>
+        <p:style>
+          <a:lnRef idx="1">
+            <a:schemeClr val="accent1"/>
+          </a:lnRef>
+          <a:fillRef idx="3">
+            <a:schemeClr val="accent1"/>
+          </a:fillRef>
+          <a:effectRef idx="2">
+            <a:schemeClr val="accent1"/>
+          </a:effectRef>
+          <a:fontRef idx="minor">
+            <a:schemeClr val="lt1"/>
+          </a:fontRef>
+        </p:style>
+        <p:txBody>
+          <a:bodyPr rtlCol="0" anchor="ctr"/>
+          <a:lstStyle/>
+          <a:p>
+            <a:pPr algn="ctr"/>
+          </a:p>
+        </p:txBody>
+      </p:sp>
+      <p:sp>
+        <p:nvSpPr>
+          <p:cNvPr id="6" name="Rectangle 5"/>
+          <p:cNvSpPr/>
+          <p:nvPr/>
+        </p:nvSpPr>
+        <p:spPr>
+          <a:xfrm>
+            <a:off x="685800" y="502920"/>
+            <a:ext cx="36576" cy="658368"/>
+          </a:xfrm>
+          <a:prstGeom prst="rect">
+            <a:avLst/>
+          </a:prstGeom>
+          <a:solidFill>
+            <a:srgbClr val="D9C089"/>
+          </a:solidFill>
+          <a:ln>
+            <a:noFill/>
+          </a:ln>
+        </p:spPr>
+        <p:style>
+          <a:lnRef idx="1">
+            <a:schemeClr val="accent1"/>
+          </a:lnRef>
+          <a:fillRef idx="3">
+            <a:schemeClr val="accent1"/>
+          </a:fillRef>
+          <a:effectRef idx="2">
+            <a:schemeClr val="accent1"/>
+          </a:effectRef>
+          <a:fontRef idx="minor">
+            <a:schemeClr val="lt1"/>
+          </a:fontRef>
+        </p:style>
+        <p:txBody>
+          <a:bodyPr rtlCol="0" anchor="ctr"/>
+          <a:lstStyle/>
+          <a:p>
+            <a:pPr algn="ctr"/>
+          </a:p>
+        </p:txBody>
+      </p:sp>
+      <p:sp>
+        <p:nvSpPr>
+          <p:cNvPr id="7" name="TextBox 6"/>
+          <p:cNvSpPr txBox="1"/>
+          <p:nvPr/>
+        </p:nvSpPr>
+        <p:spPr>
+          <a:xfrm>
+            <a:off x="813816" y="502920"/>
+            <a:ext cx="10634472" cy="685800"/>
+          </a:xfrm>
+          <a:prstGeom prst="rect">
+            <a:avLst/>
+          </a:prstGeom>
+          <a:noFill/>
+        </p:spPr>
+        <p:txBody>
+          <a:bodyPr wrap="square">
+            <a:spAutoFit/>
+          </a:bodyPr>
+          <a:lstStyle/>
+          <a:p>
+            <a:pPr algn="l"/>
+            <a:r>
+              <a:rPr sz="2400" b="1" i="0">
+                <a:solidFill>
+                  <a:srgbClr val="1F2C56"/>
+                </a:solidFill>
+                <a:latin typeface="Arial"/>
+              </a:rPr>
+              <a:t>Prinzip dieses Moduls</a:t>
+            </a:r>
+          </a:p>
+        </p:txBody>
+      </p:sp>
+      <p:sp>
+        <p:nvSpPr>
+          <p:cNvPr id="8" name="TextBox 7"/>
+          <p:cNvSpPr txBox="1"/>
+          <p:nvPr/>
+        </p:nvSpPr>
+        <p:spPr>
+          <a:xfrm>
+            <a:off x="685800" y="1417320"/>
+            <a:ext cx="10817352" cy="4892040"/>
+          </a:xfrm>
+          <a:prstGeom prst="rect">
+            <a:avLst/>
+          </a:prstGeom>
+          <a:noFill/>
+        </p:spPr>
+        <p:txBody>
+          <a:bodyPr wrap="square" anchor="ctr">
+            <a:spAutoFit/>
+          </a:bodyPr>
+          <a:lstStyle/>
+          <a:p>
+            <a:pPr marL="177800" indent="-177800">
+              <a:spcBef>
+                <a:spcPts val="600"/>
+              </a:spcBef>
+              <a:spcAft>
+                <a:spcPts val="200"/>
+              </a:spcAft>
+            </a:pPr>
+            <a:r>
+              <a:rPr sz="1200" i="1">
+                <a:solidFill>
+                  <a:srgbClr val="3D5466"/>
+                </a:solidFill>
+                <a:latin typeface="Arial"/>
+              </a:rPr>
+              <a:t>→  Am Telefon zählt nicht nur, was du sagst, sondern wie es ankommt.</a:t>
+            </a:r>
+          </a:p>
+          <a:p>
+            <a:pPr marL="190500" indent="-190500">
+              <a:spcBef>
+                <a:spcPts val="400"/>
+              </a:spcBef>
+              <a:spcAft>
+                <a:spcPts val="200"/>
+              </a:spcAft>
+            </a:pPr>
+            <a:r>
+              <a:rPr sz="1300">
+                <a:solidFill>
+                  <a:srgbClr val="3D5466"/>
+                </a:solidFill>
+                <a:latin typeface="Arial"/>
+              </a:rPr>
+              <a:t>▸  Inhalts- und Beziehungsebene trennen; ein strukturiertes, freundliches Gespräch ist gelebter Kundenservice.</a:t>
+            </a:r>
+          </a:p>
+        </p:txBody>
+      </p:sp>
+      <p:sp>
+        <p:nvSpPr>
+          <p:cNvPr id="9" name="Rectangle 8"/>
+          <p:cNvSpPr/>
+          <p:nvPr/>
+        </p:nvSpPr>
+        <p:spPr>
+          <a:xfrm>
+            <a:off x="0" y="6510528"/>
+            <a:ext cx="12188952" cy="347472"/>
+          </a:xfrm>
+          <a:prstGeom prst="rect">
+            <a:avLst/>
+          </a:prstGeom>
+          <a:solidFill>
+            <a:srgbClr val="0A1937"/>
+          </a:solidFill>
+          <a:ln>
+            <a:noFill/>
+          </a:ln>
+        </p:spPr>
+        <p:style>
+          <a:lnRef idx="1">
+            <a:schemeClr val="accent1"/>
+          </a:lnRef>
+          <a:fillRef idx="3">
+            <a:schemeClr val="accent1"/>
+          </a:fillRef>
+          <a:effectRef idx="2">
+            <a:schemeClr val="accent1"/>
+          </a:effectRef>
+          <a:fontRef idx="minor">
+            <a:schemeClr val="lt1"/>
+          </a:fontRef>
+        </p:style>
+        <p:txBody>
+          <a:bodyPr rtlCol="0" anchor="ctr"/>
+          <a:lstStyle/>
+          <a:p>
+            <a:pPr algn="ctr"/>
+          </a:p>
+        </p:txBody>
+      </p:sp>
+      <p:sp>
+        <p:nvSpPr>
+          <p:cNvPr id="10" name="TextBox 9"/>
+          <p:cNvSpPr txBox="1"/>
+          <p:nvPr/>
+        </p:nvSpPr>
+        <p:spPr>
+          <a:xfrm>
+            <a:off x="685800" y="6583680"/>
+            <a:ext cx="6490411" cy="256032"/>
+          </a:xfrm>
+          <a:prstGeom prst="rect">
+            <a:avLst/>
+          </a:prstGeom>
+          <a:noFill/>
+        </p:spPr>
+        <p:txBody>
+          <a:bodyPr wrap="none">
+            <a:spAutoFit/>
+          </a:bodyPr>
+          <a:lstStyle/>
+          <a:p>
+            <a:pPr algn="l"/>
+            <a:r>
+              <a:rPr sz="700">
+                <a:solidFill>
+                  <a:srgbClr val="A0B4D2"/>
+                </a:solidFill>
+                <a:latin typeface="Consolas"/>
+              </a:rPr>
+              <a:t>FKB Campus  ·  VA05</a:t>
+            </a:r>
+          </a:p>
+        </p:txBody>
+      </p:sp>
+    </p:spTree>
+  </p:cSld>
+  <p:clrMapOvr>
+    <a:masterClrMapping/>
+  </p:clrMapOvr>
+</p:sld>
+</file>
+
+<file path=ppt/slides/slide16.xml><?xml version="1.0" encoding="utf-8"?>
+<p:sld xmlns:a="http://schemas.openxmlformats.org/drawingml/2006/main" xmlns:p="http://schemas.openxmlformats.org/presentationml/2006/main" xmlns:r="http://schemas.openxmlformats.org/officeDocument/2006/relationships">
+  <p:cSld>
+    <p:spTree>
+      <p:nvGrpSpPr>
+        <p:cNvPr id="1" name=""/>
+        <p:cNvGrpSpPr/>
+        <p:nvPr/>
+      </p:nvGrpSpPr>
+      <p:grpSpPr/>
+      <p:sp>
+        <p:nvSpPr>
+          <p:cNvPr id="2" name="Rectangle 1"/>
+          <p:cNvSpPr/>
+          <p:nvPr/>
+        </p:nvSpPr>
+        <p:spPr>
+          <a:xfrm>
+            <a:off x="0" y="0"/>
+            <a:ext cx="12188952" cy="6858000"/>
+          </a:xfrm>
+          <a:prstGeom prst="rect">
+            <a:avLst/>
+          </a:prstGeom>
+          <a:solidFill>
+            <a:srgbClr val="EDEDF3"/>
+          </a:solidFill>
+          <a:ln>
+            <a:noFill/>
+          </a:ln>
+        </p:spPr>
+        <p:style>
+          <a:lnRef idx="1">
+            <a:schemeClr val="accent1"/>
+          </a:lnRef>
+          <a:fillRef idx="3">
+            <a:schemeClr val="accent1"/>
+          </a:fillRef>
+          <a:effectRef idx="2">
+            <a:schemeClr val="accent1"/>
+          </a:effectRef>
+          <a:fontRef idx="minor">
+            <a:schemeClr val="lt1"/>
+          </a:fontRef>
+        </p:style>
+        <p:txBody>
+          <a:bodyPr rtlCol="0" anchor="ctr"/>
+          <a:lstStyle/>
+          <a:p>
+            <a:pPr algn="ctr"/>
+          </a:p>
+        </p:txBody>
+      </p:sp>
+      <p:sp>
+        <p:nvSpPr>
+          <p:cNvPr id="3" name="Rectangle 2"/>
+          <p:cNvSpPr/>
+          <p:nvPr/>
+        </p:nvSpPr>
+        <p:spPr>
+          <a:xfrm>
+            <a:off x="0" y="0"/>
+            <a:ext cx="12188952" cy="50292"/>
+          </a:xfrm>
+          <a:prstGeom prst="rect">
+            <a:avLst/>
+          </a:prstGeom>
+          <a:solidFill>
+            <a:srgbClr val="1F2C56"/>
+          </a:solidFill>
+          <a:ln>
+            <a:noFill/>
+          </a:ln>
+        </p:spPr>
+        <p:style>
+          <a:lnRef idx="1">
+            <a:schemeClr val="accent1"/>
+          </a:lnRef>
+          <a:fillRef idx="3">
+            <a:schemeClr val="accent1"/>
+          </a:fillRef>
+          <a:effectRef idx="2">
+            <a:schemeClr val="accent1"/>
+          </a:effectRef>
+          <a:fontRef idx="minor">
+            <a:schemeClr val="lt1"/>
+          </a:fontRef>
+        </p:style>
+        <p:txBody>
+          <a:bodyPr rtlCol="0" anchor="ctr"/>
+          <a:lstStyle/>
+          <a:p>
+            <a:pPr algn="ctr"/>
+          </a:p>
+        </p:txBody>
+      </p:sp>
+      <p:sp>
+        <p:nvSpPr>
+          <p:cNvPr id="4" name="TextBox 3"/>
+          <p:cNvSpPr txBox="1"/>
+          <p:nvPr/>
+        </p:nvSpPr>
+        <p:spPr>
+          <a:xfrm>
+            <a:off x="685800" y="109728"/>
+            <a:ext cx="10817352" cy="228600"/>
+          </a:xfrm>
+          <a:prstGeom prst="rect">
+            <a:avLst/>
+          </a:prstGeom>
+          <a:noFill/>
+        </p:spPr>
+        <p:txBody>
+          <a:bodyPr wrap="none">
+            <a:spAutoFit/>
+          </a:bodyPr>
+          <a:lstStyle/>
+          <a:p>
+            <a:pPr algn="l"/>
+            <a:r>
+              <a:rPr sz="750">
+                <a:solidFill>
+                  <a:srgbClr val="78808C"/>
+                </a:solidFill>
+                <a:latin typeface="Consolas"/>
+              </a:rPr>
+              <a:t>VA05  ·  INHALT</a:t>
+            </a:r>
+          </a:p>
+        </p:txBody>
+      </p:sp>
+      <p:sp>
+        <p:nvSpPr>
+          <p:cNvPr id="5" name="Rectangle 4"/>
+          <p:cNvSpPr/>
+          <p:nvPr/>
+        </p:nvSpPr>
+        <p:spPr>
+          <a:xfrm>
+            <a:off x="0" y="1234440"/>
+            <a:ext cx="12188952" cy="12700"/>
+          </a:xfrm>
+          <a:prstGeom prst="rect">
+            <a:avLst/>
+          </a:prstGeom>
+          <a:solidFill>
+            <a:srgbClr val="D8DFE4"/>
+          </a:solidFill>
+          <a:ln>
+            <a:noFill/>
+          </a:ln>
+        </p:spPr>
+        <p:style>
+          <a:lnRef idx="1">
+            <a:schemeClr val="accent1"/>
+          </a:lnRef>
+          <a:fillRef idx="3">
+            <a:schemeClr val="accent1"/>
+          </a:fillRef>
+          <a:effectRef idx="2">
+            <a:schemeClr val="accent1"/>
+          </a:effectRef>
+          <a:fontRef idx="minor">
+            <a:schemeClr val="lt1"/>
+          </a:fontRef>
+        </p:style>
+        <p:txBody>
+          <a:bodyPr rtlCol="0" anchor="ctr"/>
+          <a:lstStyle/>
+          <a:p>
+            <a:pPr algn="ctr"/>
+          </a:p>
+        </p:txBody>
+      </p:sp>
+      <p:sp>
+        <p:nvSpPr>
+          <p:cNvPr id="6" name="Rectangle 5"/>
+          <p:cNvSpPr/>
+          <p:nvPr/>
+        </p:nvSpPr>
+        <p:spPr>
+          <a:xfrm>
+            <a:off x="685800" y="502920"/>
+            <a:ext cx="36576" cy="658368"/>
+          </a:xfrm>
+          <a:prstGeom prst="rect">
+            <a:avLst/>
+          </a:prstGeom>
+          <a:solidFill>
+            <a:srgbClr val="D9C089"/>
+          </a:solidFill>
+          <a:ln>
+            <a:noFill/>
+          </a:ln>
+        </p:spPr>
+        <p:style>
+          <a:lnRef idx="1">
+            <a:schemeClr val="accent1"/>
+          </a:lnRef>
+          <a:fillRef idx="3">
+            <a:schemeClr val="accent1"/>
+          </a:fillRef>
+          <a:effectRef idx="2">
+            <a:schemeClr val="accent1"/>
+          </a:effectRef>
+          <a:fontRef idx="minor">
+            <a:schemeClr val="lt1"/>
+          </a:fontRef>
+        </p:style>
+        <p:txBody>
+          <a:bodyPr rtlCol="0" anchor="ctr"/>
+          <a:lstStyle/>
+          <a:p>
+            <a:pPr algn="ctr"/>
+          </a:p>
+        </p:txBody>
+      </p:sp>
+      <p:sp>
+        <p:nvSpPr>
+          <p:cNvPr id="7" name="TextBox 6"/>
+          <p:cNvSpPr txBox="1"/>
+          <p:nvPr/>
+        </p:nvSpPr>
+        <p:spPr>
+          <a:xfrm>
+            <a:off x="813816" y="502920"/>
+            <a:ext cx="10634472" cy="685800"/>
+          </a:xfrm>
+          <a:prstGeom prst="rect">
+            <a:avLst/>
+          </a:prstGeom>
+          <a:noFill/>
+        </p:spPr>
+        <p:txBody>
+          <a:bodyPr wrap="square">
+            <a:spAutoFit/>
+          </a:bodyPr>
+          <a:lstStyle/>
+          <a:p>
+            <a:pPr algn="l"/>
+            <a:r>
+              <a:rPr sz="2400" b="1" i="0">
+                <a:solidFill>
+                  <a:srgbClr val="1F2C56"/>
+                </a:solidFill>
+                <a:latin typeface="Arial"/>
+              </a:rPr>
+              <a:t>Reflexionsfragen</a:t>
+            </a:r>
+          </a:p>
+        </p:txBody>
+      </p:sp>
+      <p:sp>
+        <p:nvSpPr>
+          <p:cNvPr id="8" name="TextBox 7"/>
+          <p:cNvSpPr txBox="1"/>
+          <p:nvPr/>
+        </p:nvSpPr>
+        <p:spPr>
+          <a:xfrm>
+            <a:off x="685800" y="1417320"/>
+            <a:ext cx="10817352" cy="4892040"/>
+          </a:xfrm>
+          <a:prstGeom prst="rect">
+            <a:avLst/>
+          </a:prstGeom>
+          <a:noFill/>
+        </p:spPr>
+        <p:txBody>
+          <a:bodyPr wrap="square" anchor="ctr">
+            <a:spAutoFit/>
+          </a:bodyPr>
+          <a:lstStyle/>
+          <a:p>
+            <a:pPr marL="190500" indent="-190500">
+              <a:spcBef>
+                <a:spcPts val="400"/>
+              </a:spcBef>
+              <a:spcAft>
+                <a:spcPts val="200"/>
+              </a:spcAft>
+            </a:pPr>
+            <a:r>
+              <a:rPr sz="1300">
+                <a:solidFill>
+                  <a:srgbClr val="3D5466"/>
+                </a:solidFill>
+                <a:latin typeface="Arial"/>
+              </a:rPr>
+              <a:t>▸  Welche der vier SERVQUAL-Dimensionen verletzen Sie im Alltag am häufigsten – und was wäre die kleinste Änderung?</a:t>
+            </a:r>
+          </a:p>
+          <a:p>
+            <a:pPr marL="190500" indent="-190500">
+              <a:spcBef>
+                <a:spcPts val="400"/>
+              </a:spcBef>
+              <a:spcAft>
+                <a:spcPts val="200"/>
+              </a:spcAft>
+            </a:pPr>
+            <a:r>
+              <a:rPr sz="1300">
+                <a:solidFill>
+                  <a:srgbClr val="3D5466"/>
+                </a:solidFill>
+                <a:latin typeface="Arial"/>
+              </a:rPr>
+              <a:t>▸  Welcher erste Satz zeigt einem verärgerten Kunden, dass Sie ihn ernst nehmen?</a:t>
+            </a:r>
+          </a:p>
+          <a:p>
+            <a:pPr marL="190500" indent="-190500">
+              <a:spcBef>
+                <a:spcPts val="400"/>
+              </a:spcBef>
+              <a:spcAft>
+                <a:spcPts val="200"/>
+              </a:spcAft>
+            </a:pPr>
+            <a:r>
+              <a:rPr sz="1300">
+                <a:solidFill>
+                  <a:srgbClr val="3D5466"/>
+                </a:solidFill>
+                <a:latin typeface="Arial"/>
+              </a:rPr>
+              <a:t>▸  Woran merken Sie selbst, dass Sie zu früh von der Beziehung zur Sache gewechselt sind?</a:t>
+            </a:r>
+          </a:p>
+        </p:txBody>
+      </p:sp>
+      <p:sp>
+        <p:nvSpPr>
+          <p:cNvPr id="9" name="Rectangle 8"/>
+          <p:cNvSpPr/>
+          <p:nvPr/>
+        </p:nvSpPr>
+        <p:spPr>
+          <a:xfrm>
+            <a:off x="0" y="6510528"/>
+            <a:ext cx="12188952" cy="347472"/>
+          </a:xfrm>
+          <a:prstGeom prst="rect">
+            <a:avLst/>
+          </a:prstGeom>
+          <a:solidFill>
+            <a:srgbClr val="0A1937"/>
+          </a:solidFill>
+          <a:ln>
+            <a:noFill/>
+          </a:ln>
+        </p:spPr>
+        <p:style>
+          <a:lnRef idx="1">
+            <a:schemeClr val="accent1"/>
+          </a:lnRef>
+          <a:fillRef idx="3">
+            <a:schemeClr val="accent1"/>
+          </a:fillRef>
+          <a:effectRef idx="2">
+            <a:schemeClr val="accent1"/>
+          </a:effectRef>
+          <a:fontRef idx="minor">
+            <a:schemeClr val="lt1"/>
+          </a:fontRef>
+        </p:style>
+        <p:txBody>
+          <a:bodyPr rtlCol="0" anchor="ctr"/>
+          <a:lstStyle/>
+          <a:p>
+            <a:pPr algn="ctr"/>
+          </a:p>
+        </p:txBody>
+      </p:sp>
+      <p:sp>
+        <p:nvSpPr>
+          <p:cNvPr id="10" name="TextBox 9"/>
+          <p:cNvSpPr txBox="1"/>
+          <p:nvPr/>
+        </p:nvSpPr>
+        <p:spPr>
+          <a:xfrm>
+            <a:off x="685800" y="6583680"/>
+            <a:ext cx="6490411" cy="256032"/>
+          </a:xfrm>
+          <a:prstGeom prst="rect">
+            <a:avLst/>
+          </a:prstGeom>
+          <a:noFill/>
+        </p:spPr>
+        <p:txBody>
+          <a:bodyPr wrap="none">
+            <a:spAutoFit/>
+          </a:bodyPr>
+          <a:lstStyle/>
+          <a:p>
+            <a:pPr algn="l"/>
+            <a:r>
+              <a:rPr sz="700">
+                <a:solidFill>
+                  <a:srgbClr val="A0B4D2"/>
+                </a:solidFill>
+                <a:latin typeface="Consolas"/>
+              </a:rPr>
+              <a:t>FKB Campus  ·  VA05</a:t>
+            </a:r>
+          </a:p>
+        </p:txBody>
+      </p:sp>
+    </p:spTree>
+  </p:cSld>
+  <p:clrMapOvr>
+    <a:masterClrMapping/>
+  </p:clrMapOvr>
+</p:sld>
+</file>
+
 <file path=ppt/slides/slide2.xml><?xml version="1.0" encoding="utf-8"?>
 <p:sld xmlns:a="http://schemas.openxmlformats.org/drawingml/2006/main" xmlns:p="http://schemas.openxmlformats.org/presentationml/2006/main" xmlns:r="http://schemas.openxmlformats.org/officeDocument/2006/relationships">
   <p:cSld>
@@ -5759,7 +8917,7 @@
             <a:avLst/>
           </a:prstGeom>
           <a:solidFill>
-            <a:srgbClr val="EDEDF3"/>
+            <a:srgbClr val="1F2C56"/>
           </a:solidFill>
           <a:ln>
             <a:noFill/>
@@ -5789,57 +8947,14 @@
       </p:sp>
       <p:sp>
         <p:nvSpPr>
-          <p:cNvPr id="3" name="Rectangle 2"/>
-          <p:cNvSpPr/>
-          <p:nvPr/>
-        </p:nvSpPr>
-        <p:spPr>
-          <a:xfrm>
-            <a:off x="0" y="0"/>
-            <a:ext cx="12188952" cy="50292"/>
-          </a:xfrm>
-          <a:prstGeom prst="rect">
-            <a:avLst/>
-          </a:prstGeom>
-          <a:solidFill>
-            <a:srgbClr val="1F2C56"/>
-          </a:solidFill>
-          <a:ln>
-            <a:noFill/>
-          </a:ln>
-        </p:spPr>
-        <p:style>
-          <a:lnRef idx="1">
-            <a:schemeClr val="accent1"/>
-          </a:lnRef>
-          <a:fillRef idx="3">
-            <a:schemeClr val="accent1"/>
-          </a:fillRef>
-          <a:effectRef idx="2">
-            <a:schemeClr val="accent1"/>
-          </a:effectRef>
-          <a:fontRef idx="minor">
-            <a:schemeClr val="lt1"/>
-          </a:fontRef>
-        </p:style>
-        <p:txBody>
-          <a:bodyPr rtlCol="0" anchor="ctr"/>
-          <a:lstStyle/>
-          <a:p>
-            <a:pPr algn="ctr"/>
-          </a:p>
-        </p:txBody>
-      </p:sp>
-      <p:sp>
-        <p:nvSpPr>
-          <p:cNvPr id="4" name="TextBox 3"/>
+          <p:cNvPr id="3" name="TextBox 2"/>
           <p:cNvSpPr txBox="1"/>
           <p:nvPr/>
         </p:nvSpPr>
         <p:spPr>
           <a:xfrm>
-            <a:off x="685800" y="109728"/>
-            <a:ext cx="10817352" cy="228600"/>
+            <a:off x="685800" y="2377440"/>
+            <a:ext cx="10817352" cy="365760"/>
           </a:xfrm>
           <a:prstGeom prst="rect">
             <a:avLst/>
@@ -5854,70 +8969,27 @@
           <a:p>
             <a:pPr algn="l"/>
             <a:r>
-              <a:rPr sz="750">
-                <a:solidFill>
-                  <a:srgbClr val="78808C"/>
+              <a:rPr sz="1200">
+                <a:solidFill>
+                  <a:srgbClr val="D9C089"/>
                 </a:solidFill>
                 <a:latin typeface="Consolas"/>
               </a:rPr>
-              <a:t>VA05  ·  INHALT</a:t>
-            </a:r>
-          </a:p>
-        </p:txBody>
-      </p:sp>
-      <p:sp>
-        <p:nvSpPr>
-          <p:cNvPr id="5" name="Rectangle 4"/>
+              <a:t>00:05–00:20</a:t>
+            </a:r>
+          </a:p>
+        </p:txBody>
+      </p:sp>
+      <p:sp>
+        <p:nvSpPr>
+          <p:cNvPr id="4" name="Rectangle 3"/>
           <p:cNvSpPr/>
           <p:nvPr/>
         </p:nvSpPr>
         <p:spPr>
           <a:xfrm>
-            <a:off x="0" y="1234440"/>
-            <a:ext cx="12188952" cy="12700"/>
-          </a:xfrm>
-          <a:prstGeom prst="rect">
-            <a:avLst/>
-          </a:prstGeom>
-          <a:solidFill>
-            <a:srgbClr val="D8DFE4"/>
-          </a:solidFill>
-          <a:ln>
-            <a:noFill/>
-          </a:ln>
-        </p:spPr>
-        <p:style>
-          <a:lnRef idx="1">
-            <a:schemeClr val="accent1"/>
-          </a:lnRef>
-          <a:fillRef idx="3">
-            <a:schemeClr val="accent1"/>
-          </a:fillRef>
-          <a:effectRef idx="2">
-            <a:schemeClr val="accent1"/>
-          </a:effectRef>
-          <a:fontRef idx="minor">
-            <a:schemeClr val="lt1"/>
-          </a:fontRef>
-        </p:style>
-        <p:txBody>
-          <a:bodyPr rtlCol="0" anchor="ctr"/>
-          <a:lstStyle/>
-          <a:p>
-            <a:pPr algn="ctr"/>
-          </a:p>
-        </p:txBody>
-      </p:sp>
-      <p:sp>
-        <p:nvSpPr>
-          <p:cNvPr id="6" name="Rectangle 5"/>
-          <p:cNvSpPr/>
-          <p:nvPr/>
-        </p:nvSpPr>
-        <p:spPr>
-          <a:xfrm>
-            <a:off x="685800" y="502920"/>
-            <a:ext cx="36576" cy="658368"/>
+            <a:off x="685800" y="2788920"/>
+            <a:ext cx="548640" cy="38100"/>
           </a:xfrm>
           <a:prstGeom prst="rect">
             <a:avLst/>
@@ -5953,14 +9025,14 @@
       </p:sp>
       <p:sp>
         <p:nvSpPr>
-          <p:cNvPr id="7" name="TextBox 6"/>
+          <p:cNvPr id="5" name="TextBox 4"/>
           <p:cNvSpPr txBox="1"/>
           <p:nvPr/>
         </p:nvSpPr>
         <p:spPr>
           <a:xfrm>
-            <a:off x="813816" y="502920"/>
-            <a:ext cx="10634472" cy="685800"/>
+            <a:off x="685800" y="3017520"/>
+            <a:ext cx="10817352" cy="1463040"/>
           </a:xfrm>
           <a:prstGeom prst="rect">
             <a:avLst/>
@@ -5975,27 +9047,27 @@
           <a:p>
             <a:pPr algn="l"/>
             <a:r>
-              <a:rPr sz="2400" b="1" i="0">
-                <a:solidFill>
-                  <a:srgbClr val="1F2C56"/>
+              <a:rPr sz="4000" b="1" i="0">
+                <a:solidFill>
+                  <a:srgbClr val="FFFFFF"/>
                 </a:solidFill>
                 <a:latin typeface="Arial"/>
               </a:rPr>
-              <a:t>Theorie-Input: Woran Kunden Servicequalität festmachen</a:t>
-            </a:r>
-          </a:p>
-        </p:txBody>
-      </p:sp>
-      <p:sp>
-        <p:nvSpPr>
-          <p:cNvPr id="8" name="TextBox 7"/>
+              <a:t>Theorie-Input 1</a:t>
+            </a:r>
+          </a:p>
+        </p:txBody>
+      </p:sp>
+      <p:sp>
+        <p:nvSpPr>
+          <p:cNvPr id="6" name="TextBox 5"/>
           <p:cNvSpPr txBox="1"/>
           <p:nvPr/>
         </p:nvSpPr>
         <p:spPr>
           <a:xfrm>
-            <a:off x="685800" y="1417320"/>
-            <a:ext cx="10817352" cy="4892040"/>
+            <a:off x="685800" y="4480560"/>
+            <a:ext cx="8653881" cy="1280160"/>
           </a:xfrm>
           <a:prstGeom prst="rect">
             <a:avLst/>
@@ -6003,84 +9075,34 @@
           <a:noFill/>
         </p:spPr>
         <p:txBody>
-          <a:bodyPr wrap="square" anchor="ctr">
+          <a:bodyPr wrap="square">
             <a:spAutoFit/>
           </a:bodyPr>
           <a:lstStyle/>
           <a:p>
-            <a:pPr marL="190500" indent="-190500">
-              <a:spcBef>
-                <a:spcPts val="400"/>
-              </a:spcBef>
-              <a:spcAft>
-                <a:spcPts val="200"/>
-              </a:spcAft>
-            </a:pPr>
-            <a:r>
-              <a:rPr sz="1300">
-                <a:solidFill>
-                  <a:srgbClr val="3D5466"/>
+            <a:pPr algn="l"/>
+            <a:r>
+              <a:rPr sz="1600" b="0" i="0">
+                <a:solidFill>
+                  <a:srgbClr val="C8D2E6"/>
                 </a:solidFill>
                 <a:latin typeface="Arial"/>
               </a:rPr>
-              <a:t>▸  Gerade Zuverlässigkeit und Reaktionsfähigkeit sind im Bankinnendienst die am unmittelbarsten erlebten Qualitätsmerkmale: Ein zugesagter Rückruf, der kommt, schlägt jede Hochglanzbroschüre.</a:t>
-            </a:r>
-          </a:p>
-        </p:txBody>
-      </p:sp>
-      <p:sp>
-        <p:nvSpPr>
-          <p:cNvPr id="9" name="Rectangle 8"/>
-          <p:cNvSpPr/>
-          <p:nvPr/>
-        </p:nvSpPr>
-        <p:spPr>
-          <a:xfrm>
-            <a:off x="0" y="6510528"/>
-            <a:ext cx="12188952" cy="347472"/>
-          </a:xfrm>
-          <a:prstGeom prst="rect">
-            <a:avLst/>
-          </a:prstGeom>
-          <a:solidFill>
-            <a:srgbClr val="0A1937"/>
-          </a:solidFill>
-          <a:ln>
-            <a:noFill/>
-          </a:ln>
-        </p:spPr>
-        <p:style>
-          <a:lnRef idx="1">
-            <a:schemeClr val="accent1"/>
-          </a:lnRef>
-          <a:fillRef idx="3">
-            <a:schemeClr val="accent1"/>
-          </a:fillRef>
-          <a:effectRef idx="2">
-            <a:schemeClr val="accent1"/>
-          </a:effectRef>
-          <a:fontRef idx="minor">
-            <a:schemeClr val="lt1"/>
-          </a:fontRef>
-        </p:style>
-        <p:txBody>
-          <a:bodyPr rtlCol="0" anchor="ctr"/>
-          <a:lstStyle/>
-          <a:p>
-            <a:pPr algn="ctr"/>
-          </a:p>
-        </p:txBody>
-      </p:sp>
-      <p:sp>
-        <p:nvSpPr>
-          <p:cNvPr id="10" name="TextBox 9"/>
+              <a:t>Kommunikation verstehen – jede Nachricht hat vier Seiten.</a:t>
+            </a:r>
+          </a:p>
+        </p:txBody>
+      </p:sp>
+      <p:sp>
+        <p:nvSpPr>
+          <p:cNvPr id="7" name="TextBox 6"/>
           <p:cNvSpPr txBox="1"/>
           <p:nvPr/>
         </p:nvSpPr>
         <p:spPr>
           <a:xfrm>
-            <a:off x="685800" y="6583680"/>
-            <a:ext cx="6490411" cy="256032"/>
+            <a:off x="685800" y="6355080"/>
+            <a:ext cx="10817352" cy="274320"/>
           </a:xfrm>
           <a:prstGeom prst="rect">
             <a:avLst/>
@@ -6097,7 +9119,7 @@
             <a:r>
               <a:rPr sz="700">
                 <a:solidFill>
-                  <a:srgbClr val="A0B4D2"/>
+                  <a:srgbClr val="8CA0C3"/>
                 </a:solidFill>
                 <a:latin typeface="Consolas"/>
               </a:rPr>
@@ -6240,7 +9262,7 @@
                 </a:solidFill>
                 <a:latin typeface="Consolas"/>
               </a:rPr>
-              <a:t>VA05  ·  ARBEITSBLATT</a:t>
+              <a:t>VA05  ·  INHALT</a:t>
             </a:r>
           </a:p>
         </p:txBody>
@@ -6361,7 +9383,7 @@
                 </a:solidFill>
                 <a:latin typeface="Arial"/>
               </a:rPr>
-              <a:t>Praxisfall: Ein Anruf und eine Mail (Elektro Musterregion GmbH)</a:t>
+              <a:t>Erst die Beziehung, dann die Sache</a:t>
             </a:r>
           </a:p>
         </p:txBody>
@@ -6374,8 +9396,8 @@
         </p:nvSpPr>
         <p:spPr>
           <a:xfrm>
-            <a:off x="685800" y="1554480"/>
-            <a:ext cx="10817352" cy="3840480"/>
+            <a:off x="685800" y="1417320"/>
+            <a:ext cx="10817352" cy="4892040"/>
           </a:xfrm>
           <a:prstGeom prst="rect">
             <a:avLst/>
@@ -6383,10 +9405,29 @@
           <a:noFill/>
         </p:spPr>
         <p:txBody>
-          <a:bodyPr wrap="square">
+          <a:bodyPr wrap="square" anchor="ctr">
             <a:spAutoFit/>
           </a:bodyPr>
           <a:lstStyle/>
+          <a:p>
+            <a:pPr marL="177800" indent="-177800">
+              <a:spcBef>
+                <a:spcPts val="600"/>
+              </a:spcBef>
+              <a:spcAft>
+                <a:spcPts val="200"/>
+              </a:spcAft>
+            </a:pPr>
+            <a:r>
+              <a:rPr sz="1200" i="1">
+                <a:solidFill>
+                  <a:srgbClr val="3D5466"/>
+                </a:solidFill>
+                <a:latin typeface="Arial"/>
+              </a:rPr>
+              <a:t>→  Jede Äußerung enthält vier Botschaften (Schulz von Thun). Reagieren Sie zuerst auf die Beziehungsebene, dann auf den Sachinhalt (Watzlawick).</a:t>
+            </a:r>
+          </a:p>
           <a:p>
             <a:pPr marL="190500" indent="-190500">
               <a:spcBef>
@@ -6397,13 +9438,13 @@
               </a:spcAft>
             </a:pPr>
             <a:r>
-              <a:rPr sz="1400">
+              <a:rPr sz="1300">
                 <a:solidFill>
                   <a:srgbClr val="3D5466"/>
                 </a:solidFill>
                 <a:latin typeface="Arial"/>
               </a:rPr>
-              <a:t>▸  Ausgangslage (anonymisiert)</a:t>
+              <a:t>▸  Sachinhalt, Selbstoffenbarung, Beziehung und Appell schwingen in jedem Satz mit.</a:t>
             </a:r>
           </a:p>
           <a:p>
@@ -6416,13 +9457,13 @@
               </a:spcAft>
             </a:pPr>
             <a:r>
-              <a:rPr sz="1400">
+              <a:rPr sz="1300">
                 <a:solidFill>
                   <a:srgbClr val="3D5466"/>
                 </a:solidFill>
                 <a:latin typeface="Arial"/>
               </a:rPr>
-              <a:t>▸  Die Elektro Musterregion GmbH ist Firmenkundin der VR-Bank Musterregion eG. Zwei Vorgänge erreichen Sie im Innendienst:</a:t>
+              <a:t>▸  Ein verärgerter Anruf ist selten Sachkritik – meist geht es um die Beziehungsebene.</a:t>
             </a:r>
           </a:p>
           <a:p>
@@ -6435,51 +9476,13 @@
               </a:spcAft>
             </a:pPr>
             <a:r>
-              <a:rPr sz="1400">
+              <a:rPr sz="1300">
                 <a:solidFill>
                   <a:srgbClr val="3D5466"/>
                 </a:solidFill>
                 <a:latin typeface="Arial"/>
               </a:rPr>
-              <a:t>▸  Telefon: Der Geschäftsführer ruft an, hörbar verärgert: „Ist die Darlehenszusage denn immer noch nicht durch? Ich warte seit über einer Woche!" Sie wissen: Es fehlt noch eine Unterlage, der Berater ist im Termin.</a:t>
-            </a:r>
-          </a:p>
-          <a:p>
-            <a:pPr marL="190500" indent="-190500">
-              <a:spcBef>
-                <a:spcPts val="400"/>
-              </a:spcBef>
-              <a:spcAft>
-                <a:spcPts val="200"/>
-              </a:spcAft>
-            </a:pPr>
-            <a:r>
-              <a:rPr sz="1400">
-                <a:solidFill>
-                  <a:srgbClr val="3D5466"/>
-                </a:solidFill>
-                <a:latin typeface="Arial"/>
-              </a:rPr>
-              <a:t>▸  Mail: Eine Mitarbeiterin der Firma schreibt mit drei Fragen in einer Mail: Stand der Zusage, benötigte Unterlagen, möglicher Auszahlungstermin.</a:t>
-            </a:r>
-          </a:p>
-          <a:p>
-            <a:pPr marL="190500" indent="-190500">
-              <a:spcBef>
-                <a:spcPts val="400"/>
-              </a:spcBef>
-              <a:spcAft>
-                <a:spcPts val="200"/>
-              </a:spcAft>
-            </a:pPr>
-            <a:r>
-              <a:rPr sz="1400">
-                <a:solidFill>
-                  <a:srgbClr val="3D5466"/>
-                </a:solidFill>
-                <a:latin typeface="Arial"/>
-              </a:rPr>
-              <a:t>▸  Die folgende Handlungsempfehlung verknüpft typische Kommunikationssituationen mit der serviceorientierten Reaktion – nutzen Sie sie bei der Fallarbeit.</a:t>
+              <a:t>▸  Wer zuerst Verständnis zeigt, entschärft den Ärger, bevor er die Sachlage erklärt.</a:t>
             </a:r>
           </a:p>
         </p:txBody>
@@ -6487,84 +9490,6 @@
       <p:sp>
         <p:nvSpPr>
           <p:cNvPr id="9" name="Rectangle 8"/>
-          <p:cNvSpPr/>
-          <p:nvPr/>
-        </p:nvSpPr>
-        <p:spPr>
-          <a:xfrm>
-            <a:off x="685800" y="5486400"/>
-            <a:ext cx="10817352" cy="640080"/>
-          </a:xfrm>
-          <a:prstGeom prst="rect">
-            <a:avLst/>
-          </a:prstGeom>
-          <a:solidFill>
-            <a:srgbClr val="1F2C56"/>
-          </a:solidFill>
-          <a:ln>
-            <a:noFill/>
-          </a:ln>
-        </p:spPr>
-        <p:style>
-          <a:lnRef idx="1">
-            <a:schemeClr val="accent1"/>
-          </a:lnRef>
-          <a:fillRef idx="3">
-            <a:schemeClr val="accent1"/>
-          </a:fillRef>
-          <a:effectRef idx="2">
-            <a:schemeClr val="accent1"/>
-          </a:effectRef>
-          <a:fontRef idx="minor">
-            <a:schemeClr val="lt1"/>
-          </a:fontRef>
-        </p:style>
-        <p:txBody>
-          <a:bodyPr rtlCol="0" anchor="ctr"/>
-          <a:lstStyle/>
-          <a:p>
-            <a:pPr algn="ctr"/>
-          </a:p>
-        </p:txBody>
-      </p:sp>
-      <p:sp>
-        <p:nvSpPr>
-          <p:cNvPr id="10" name="TextBox 9"/>
-          <p:cNvSpPr txBox="1"/>
-          <p:nvPr/>
-        </p:nvSpPr>
-        <p:spPr>
-          <a:xfrm>
-            <a:off x="868680" y="5596128"/>
-            <a:ext cx="10451592" cy="457200"/>
-          </a:xfrm>
-          <a:prstGeom prst="rect">
-            <a:avLst/>
-          </a:prstGeom>
-          <a:noFill/>
-        </p:spPr>
-        <p:txBody>
-          <a:bodyPr wrap="square">
-            <a:spAutoFit/>
-          </a:bodyPr>
-          <a:lstStyle/>
-          <a:p>
-            <a:pPr algn="l"/>
-            <a:r>
-              <a:rPr sz="1300" b="1" i="0">
-                <a:solidFill>
-                  <a:srgbClr val="FFFFFF"/>
-                </a:solidFill>
-                <a:latin typeface="Arial"/>
-              </a:rPr>
-              <a:t>→  Bearbeitung im Teilnehmer-Workbook (Arbeitsblatt mit Ausfüllfeldern)</a:t>
-            </a:r>
-          </a:p>
-        </p:txBody>
-      </p:sp>
-      <p:sp>
-        <p:nvSpPr>
-          <p:cNvPr id="11" name="Rectangle 10"/>
           <p:cNvSpPr/>
           <p:nvPr/>
         </p:nvSpPr>
@@ -6607,7 +9532,7 @@
       </p:sp>
       <p:sp>
         <p:nvSpPr>
-          <p:cNvPr id="12" name="TextBox 11"/>
+          <p:cNvPr id="10" name="TextBox 9"/>
           <p:cNvSpPr txBox="1"/>
           <p:nvPr/>
         </p:nvSpPr>
@@ -6673,7 +9598,7 @@
             <a:avLst/>
           </a:prstGeom>
           <a:solidFill>
-            <a:srgbClr val="EDEDF3"/>
+            <a:srgbClr val="FFFFFF"/>
           </a:solidFill>
           <a:ln>
             <a:noFill/>
@@ -6774,6 +9699,604 @@
                 </a:solidFill>
                 <a:latin typeface="Consolas"/>
               </a:rPr>
+              <a:t>VA05  ·  SCHAUBILD</a:t>
+            </a:r>
+          </a:p>
+        </p:txBody>
+      </p:sp>
+      <p:sp>
+        <p:nvSpPr>
+          <p:cNvPr id="5" name="TextBox 4"/>
+          <p:cNvSpPr txBox="1"/>
+          <p:nvPr/>
+        </p:nvSpPr>
+        <p:spPr>
+          <a:xfrm>
+            <a:off x="685800" y="502920"/>
+            <a:ext cx="10817352" cy="594360"/>
+          </a:xfrm>
+          <a:prstGeom prst="rect">
+            <a:avLst/>
+          </a:prstGeom>
+          <a:noFill/>
+        </p:spPr>
+        <p:txBody>
+          <a:bodyPr wrap="square">
+            <a:spAutoFit/>
+          </a:bodyPr>
+          <a:lstStyle/>
+          <a:p>
+            <a:pPr algn="l"/>
+            <a:r>
+              <a:rPr sz="2000" b="1" i="0">
+                <a:solidFill>
+                  <a:srgbClr val="1F2C56"/>
+                </a:solidFill>
+                <a:latin typeface="Arial"/>
+              </a:rPr>
+              <a:t>Die vier Seiten einer Nachricht (Schulz von Thun)</a:t>
+            </a:r>
+          </a:p>
+        </p:txBody>
+      </p:sp>
+      <p:sp>
+        <p:nvSpPr>
+          <p:cNvPr id="6" name="Rectangle 5"/>
+          <p:cNvSpPr/>
+          <p:nvPr/>
+        </p:nvSpPr>
+        <p:spPr>
+          <a:xfrm>
+            <a:off x="685800" y="1143000"/>
+            <a:ext cx="10817352" cy="25400"/>
+          </a:xfrm>
+          <a:prstGeom prst="rect">
+            <a:avLst/>
+          </a:prstGeom>
+          <a:solidFill>
+            <a:srgbClr val="D9C089"/>
+          </a:solidFill>
+          <a:ln>
+            <a:noFill/>
+          </a:ln>
+        </p:spPr>
+        <p:style>
+          <a:lnRef idx="1">
+            <a:schemeClr val="accent1"/>
+          </a:lnRef>
+          <a:fillRef idx="3">
+            <a:schemeClr val="accent1"/>
+          </a:fillRef>
+          <a:effectRef idx="2">
+            <a:schemeClr val="accent1"/>
+          </a:effectRef>
+          <a:fontRef idx="minor">
+            <a:schemeClr val="lt1"/>
+          </a:fontRef>
+        </p:style>
+        <p:txBody>
+          <a:bodyPr rtlCol="0" anchor="ctr"/>
+          <a:lstStyle/>
+          <a:p>
+            <a:pPr algn="ctr"/>
+          </a:p>
+        </p:txBody>
+      </p:sp>
+      <p:pic>
+        <p:nvPicPr>
+          <p:cNvPr id="7" name="Picture 6" descr="image.png"/>
+          <p:cNvPicPr>
+            <a:picLocks noChangeAspect="1"/>
+          </p:cNvPicPr>
+          <p:nvPr/>
+        </p:nvPicPr>
+        <p:blipFill>
+          <a:blip r:embed="rId2"/>
+          <a:stretch>
+            <a:fillRect/>
+          </a:stretch>
+        </p:blipFill>
+        <p:spPr>
+          <a:xfrm>
+            <a:off x="2009463" y="1325880"/>
+            <a:ext cx="8170026" cy="4937760"/>
+          </a:xfrm>
+          <a:prstGeom prst="rect">
+            <a:avLst/>
+          </a:prstGeom>
+        </p:spPr>
+      </p:pic>
+      <p:sp>
+        <p:nvSpPr>
+          <p:cNvPr id="8" name="Rectangle 7"/>
+          <p:cNvSpPr/>
+          <p:nvPr/>
+        </p:nvSpPr>
+        <p:spPr>
+          <a:xfrm>
+            <a:off x="0" y="6510528"/>
+            <a:ext cx="12188952" cy="347472"/>
+          </a:xfrm>
+          <a:prstGeom prst="rect">
+            <a:avLst/>
+          </a:prstGeom>
+          <a:solidFill>
+            <a:srgbClr val="0A1937"/>
+          </a:solidFill>
+          <a:ln>
+            <a:noFill/>
+          </a:ln>
+        </p:spPr>
+        <p:style>
+          <a:lnRef idx="1">
+            <a:schemeClr val="accent1"/>
+          </a:lnRef>
+          <a:fillRef idx="3">
+            <a:schemeClr val="accent1"/>
+          </a:fillRef>
+          <a:effectRef idx="2">
+            <a:schemeClr val="accent1"/>
+          </a:effectRef>
+          <a:fontRef idx="minor">
+            <a:schemeClr val="lt1"/>
+          </a:fontRef>
+        </p:style>
+        <p:txBody>
+          <a:bodyPr rtlCol="0" anchor="ctr"/>
+          <a:lstStyle/>
+          <a:p>
+            <a:pPr algn="ctr"/>
+          </a:p>
+        </p:txBody>
+      </p:sp>
+      <p:sp>
+        <p:nvSpPr>
+          <p:cNvPr id="9" name="TextBox 8"/>
+          <p:cNvSpPr txBox="1"/>
+          <p:nvPr/>
+        </p:nvSpPr>
+        <p:spPr>
+          <a:xfrm>
+            <a:off x="685800" y="6583680"/>
+            <a:ext cx="6490411" cy="256032"/>
+          </a:xfrm>
+          <a:prstGeom prst="rect">
+            <a:avLst/>
+          </a:prstGeom>
+          <a:noFill/>
+        </p:spPr>
+        <p:txBody>
+          <a:bodyPr wrap="none">
+            <a:spAutoFit/>
+          </a:bodyPr>
+          <a:lstStyle/>
+          <a:p>
+            <a:pPr algn="l"/>
+            <a:r>
+              <a:rPr sz="700">
+                <a:solidFill>
+                  <a:srgbClr val="A0B4D2"/>
+                </a:solidFill>
+                <a:latin typeface="Consolas"/>
+              </a:rPr>
+              <a:t>FKB Campus  ·  VA05</a:t>
+            </a:r>
+          </a:p>
+        </p:txBody>
+      </p:sp>
+      <p:sp>
+        <p:nvSpPr>
+          <p:cNvPr id="10" name="TextBox 9"/>
+          <p:cNvSpPr txBox="1"/>
+          <p:nvPr/>
+        </p:nvSpPr>
+        <p:spPr>
+          <a:xfrm>
+            <a:off x="7176211" y="6583680"/>
+            <a:ext cx="4326940" cy="256032"/>
+          </a:xfrm>
+          <a:prstGeom prst="rect">
+            <a:avLst/>
+          </a:prstGeom>
+          <a:noFill/>
+        </p:spPr>
+        <p:txBody>
+          <a:bodyPr wrap="none">
+            <a:spAutoFit/>
+          </a:bodyPr>
+          <a:lstStyle/>
+          <a:p>
+            <a:pPr algn="r"/>
+            <a:r>
+              <a:rPr sz="700">
+                <a:solidFill>
+                  <a:srgbClr val="A0B4D2"/>
+                </a:solidFill>
+                <a:latin typeface="Consolas"/>
+              </a:rPr>
+              <a:t>Schaubild</a:t>
+            </a:r>
+          </a:p>
+        </p:txBody>
+      </p:sp>
+    </p:spTree>
+  </p:cSld>
+  <p:clrMapOvr>
+    <a:masterClrMapping/>
+  </p:clrMapOvr>
+</p:sld>
+</file>
+
+<file path=ppt/slides/slide8.xml><?xml version="1.0" encoding="utf-8"?>
+<p:sld xmlns:a="http://schemas.openxmlformats.org/drawingml/2006/main" xmlns:p="http://schemas.openxmlformats.org/presentationml/2006/main" xmlns:r="http://schemas.openxmlformats.org/officeDocument/2006/relationships">
+  <p:cSld>
+    <p:spTree>
+      <p:nvGrpSpPr>
+        <p:cNvPr id="1" name=""/>
+        <p:cNvGrpSpPr/>
+        <p:nvPr/>
+      </p:nvGrpSpPr>
+      <p:grpSpPr/>
+      <p:sp>
+        <p:nvSpPr>
+          <p:cNvPr id="2" name="Rectangle 1"/>
+          <p:cNvSpPr/>
+          <p:nvPr/>
+        </p:nvSpPr>
+        <p:spPr>
+          <a:xfrm>
+            <a:off x="0" y="0"/>
+            <a:ext cx="12188952" cy="6858000"/>
+          </a:xfrm>
+          <a:prstGeom prst="rect">
+            <a:avLst/>
+          </a:prstGeom>
+          <a:solidFill>
+            <a:srgbClr val="1F2C56"/>
+          </a:solidFill>
+          <a:ln>
+            <a:noFill/>
+          </a:ln>
+        </p:spPr>
+        <p:style>
+          <a:lnRef idx="1">
+            <a:schemeClr val="accent1"/>
+          </a:lnRef>
+          <a:fillRef idx="3">
+            <a:schemeClr val="accent1"/>
+          </a:fillRef>
+          <a:effectRef idx="2">
+            <a:schemeClr val="accent1"/>
+          </a:effectRef>
+          <a:fontRef idx="minor">
+            <a:schemeClr val="lt1"/>
+          </a:fontRef>
+        </p:style>
+        <p:txBody>
+          <a:bodyPr rtlCol="0" anchor="ctr"/>
+          <a:lstStyle/>
+          <a:p>
+            <a:pPr algn="ctr"/>
+          </a:p>
+        </p:txBody>
+      </p:sp>
+      <p:sp>
+        <p:nvSpPr>
+          <p:cNvPr id="3" name="TextBox 2"/>
+          <p:cNvSpPr txBox="1"/>
+          <p:nvPr/>
+        </p:nvSpPr>
+        <p:spPr>
+          <a:xfrm>
+            <a:off x="685800" y="2377440"/>
+            <a:ext cx="10817352" cy="365760"/>
+          </a:xfrm>
+          <a:prstGeom prst="rect">
+            <a:avLst/>
+          </a:prstGeom>
+          <a:noFill/>
+        </p:spPr>
+        <p:txBody>
+          <a:bodyPr wrap="none">
+            <a:spAutoFit/>
+          </a:bodyPr>
+          <a:lstStyle/>
+          <a:p>
+            <a:pPr algn="l"/>
+            <a:r>
+              <a:rPr sz="1200">
+                <a:solidFill>
+                  <a:srgbClr val="D9C089"/>
+                </a:solidFill>
+                <a:latin typeface="Consolas"/>
+              </a:rPr>
+              <a:t>00:20–00:30</a:t>
+            </a:r>
+          </a:p>
+        </p:txBody>
+      </p:sp>
+      <p:sp>
+        <p:nvSpPr>
+          <p:cNvPr id="4" name="Rectangle 3"/>
+          <p:cNvSpPr/>
+          <p:nvPr/>
+        </p:nvSpPr>
+        <p:spPr>
+          <a:xfrm>
+            <a:off x="685800" y="2788920"/>
+            <a:ext cx="548640" cy="38100"/>
+          </a:xfrm>
+          <a:prstGeom prst="rect">
+            <a:avLst/>
+          </a:prstGeom>
+          <a:solidFill>
+            <a:srgbClr val="D9C089"/>
+          </a:solidFill>
+          <a:ln>
+            <a:noFill/>
+          </a:ln>
+        </p:spPr>
+        <p:style>
+          <a:lnRef idx="1">
+            <a:schemeClr val="accent1"/>
+          </a:lnRef>
+          <a:fillRef idx="3">
+            <a:schemeClr val="accent1"/>
+          </a:fillRef>
+          <a:effectRef idx="2">
+            <a:schemeClr val="accent1"/>
+          </a:effectRef>
+          <a:fontRef idx="minor">
+            <a:schemeClr val="lt1"/>
+          </a:fontRef>
+        </p:style>
+        <p:txBody>
+          <a:bodyPr rtlCol="0" anchor="ctr"/>
+          <a:lstStyle/>
+          <a:p>
+            <a:pPr algn="ctr"/>
+          </a:p>
+        </p:txBody>
+      </p:sp>
+      <p:sp>
+        <p:nvSpPr>
+          <p:cNvPr id="5" name="TextBox 4"/>
+          <p:cNvSpPr txBox="1"/>
+          <p:nvPr/>
+        </p:nvSpPr>
+        <p:spPr>
+          <a:xfrm>
+            <a:off x="685800" y="3017520"/>
+            <a:ext cx="10817352" cy="1463040"/>
+          </a:xfrm>
+          <a:prstGeom prst="rect">
+            <a:avLst/>
+          </a:prstGeom>
+          <a:noFill/>
+        </p:spPr>
+        <p:txBody>
+          <a:bodyPr wrap="square">
+            <a:spAutoFit/>
+          </a:bodyPr>
+          <a:lstStyle/>
+          <a:p>
+            <a:pPr algn="l"/>
+            <a:r>
+              <a:rPr sz="4000" b="1" i="0">
+                <a:solidFill>
+                  <a:srgbClr val="FFFFFF"/>
+                </a:solidFill>
+                <a:latin typeface="Arial"/>
+              </a:rPr>
+              <a:t>Theorie-Input 2</a:t>
+            </a:r>
+          </a:p>
+        </p:txBody>
+      </p:sp>
+      <p:sp>
+        <p:nvSpPr>
+          <p:cNvPr id="6" name="TextBox 5"/>
+          <p:cNvSpPr txBox="1"/>
+          <p:nvPr/>
+        </p:nvSpPr>
+        <p:spPr>
+          <a:xfrm>
+            <a:off x="685800" y="4480560"/>
+            <a:ext cx="8653881" cy="1280160"/>
+          </a:xfrm>
+          <a:prstGeom prst="rect">
+            <a:avLst/>
+          </a:prstGeom>
+          <a:noFill/>
+        </p:spPr>
+        <p:txBody>
+          <a:bodyPr wrap="square">
+            <a:spAutoFit/>
+          </a:bodyPr>
+          <a:lstStyle/>
+          <a:p>
+            <a:pPr algn="l"/>
+            <a:r>
+              <a:rPr sz="1600" b="0" i="0">
+                <a:solidFill>
+                  <a:srgbClr val="C8D2E6"/>
+                </a:solidFill>
+                <a:latin typeface="Arial"/>
+              </a:rPr>
+              <a:t>Servicequalität im Innendienst – vier Dimensionen, die der Kunde spürt.</a:t>
+            </a:r>
+          </a:p>
+        </p:txBody>
+      </p:sp>
+      <p:sp>
+        <p:nvSpPr>
+          <p:cNvPr id="7" name="TextBox 6"/>
+          <p:cNvSpPr txBox="1"/>
+          <p:nvPr/>
+        </p:nvSpPr>
+        <p:spPr>
+          <a:xfrm>
+            <a:off x="685800" y="6355080"/>
+            <a:ext cx="10817352" cy="274320"/>
+          </a:xfrm>
+          <a:prstGeom prst="rect">
+            <a:avLst/>
+          </a:prstGeom>
+          <a:noFill/>
+        </p:spPr>
+        <p:txBody>
+          <a:bodyPr wrap="none">
+            <a:spAutoFit/>
+          </a:bodyPr>
+          <a:lstStyle/>
+          <a:p>
+            <a:pPr algn="l"/>
+            <a:r>
+              <a:rPr sz="700">
+                <a:solidFill>
+                  <a:srgbClr val="8CA0C3"/>
+                </a:solidFill>
+                <a:latin typeface="Consolas"/>
+              </a:rPr>
+              <a:t>FKB Campus  ·  VA05</a:t>
+            </a:r>
+          </a:p>
+        </p:txBody>
+      </p:sp>
+    </p:spTree>
+  </p:cSld>
+  <p:clrMapOvr>
+    <a:masterClrMapping/>
+  </p:clrMapOvr>
+</p:sld>
+</file>
+
+<file path=ppt/slides/slide9.xml><?xml version="1.0" encoding="utf-8"?>
+<p:sld xmlns:a="http://schemas.openxmlformats.org/drawingml/2006/main" xmlns:p="http://schemas.openxmlformats.org/presentationml/2006/main" xmlns:r="http://schemas.openxmlformats.org/officeDocument/2006/relationships">
+  <p:cSld>
+    <p:spTree>
+      <p:nvGrpSpPr>
+        <p:cNvPr id="1" name=""/>
+        <p:cNvGrpSpPr/>
+        <p:nvPr/>
+      </p:nvGrpSpPr>
+      <p:grpSpPr/>
+      <p:sp>
+        <p:nvSpPr>
+          <p:cNvPr id="2" name="Rectangle 1"/>
+          <p:cNvSpPr/>
+          <p:nvPr/>
+        </p:nvSpPr>
+        <p:spPr>
+          <a:xfrm>
+            <a:off x="0" y="0"/>
+            <a:ext cx="12188952" cy="6858000"/>
+          </a:xfrm>
+          <a:prstGeom prst="rect">
+            <a:avLst/>
+          </a:prstGeom>
+          <a:solidFill>
+            <a:srgbClr val="EDEDF3"/>
+          </a:solidFill>
+          <a:ln>
+            <a:noFill/>
+          </a:ln>
+        </p:spPr>
+        <p:style>
+          <a:lnRef idx="1">
+            <a:schemeClr val="accent1"/>
+          </a:lnRef>
+          <a:fillRef idx="3">
+            <a:schemeClr val="accent1"/>
+          </a:fillRef>
+          <a:effectRef idx="2">
+            <a:schemeClr val="accent1"/>
+          </a:effectRef>
+          <a:fontRef idx="minor">
+            <a:schemeClr val="lt1"/>
+          </a:fontRef>
+        </p:style>
+        <p:txBody>
+          <a:bodyPr rtlCol="0" anchor="ctr"/>
+          <a:lstStyle/>
+          <a:p>
+            <a:pPr algn="ctr"/>
+          </a:p>
+        </p:txBody>
+      </p:sp>
+      <p:sp>
+        <p:nvSpPr>
+          <p:cNvPr id="3" name="Rectangle 2"/>
+          <p:cNvSpPr/>
+          <p:nvPr/>
+        </p:nvSpPr>
+        <p:spPr>
+          <a:xfrm>
+            <a:off x="0" y="0"/>
+            <a:ext cx="12188952" cy="50292"/>
+          </a:xfrm>
+          <a:prstGeom prst="rect">
+            <a:avLst/>
+          </a:prstGeom>
+          <a:solidFill>
+            <a:srgbClr val="1F2C56"/>
+          </a:solidFill>
+          <a:ln>
+            <a:noFill/>
+          </a:ln>
+        </p:spPr>
+        <p:style>
+          <a:lnRef idx="1">
+            <a:schemeClr val="accent1"/>
+          </a:lnRef>
+          <a:fillRef idx="3">
+            <a:schemeClr val="accent1"/>
+          </a:fillRef>
+          <a:effectRef idx="2">
+            <a:schemeClr val="accent1"/>
+          </a:effectRef>
+          <a:fontRef idx="minor">
+            <a:schemeClr val="lt1"/>
+          </a:fontRef>
+        </p:style>
+        <p:txBody>
+          <a:bodyPr rtlCol="0" anchor="ctr"/>
+          <a:lstStyle/>
+          <a:p>
+            <a:pPr algn="ctr"/>
+          </a:p>
+        </p:txBody>
+      </p:sp>
+      <p:sp>
+        <p:nvSpPr>
+          <p:cNvPr id="4" name="TextBox 3"/>
+          <p:cNvSpPr txBox="1"/>
+          <p:nvPr/>
+        </p:nvSpPr>
+        <p:spPr>
+          <a:xfrm>
+            <a:off x="685800" y="109728"/>
+            <a:ext cx="10817352" cy="228600"/>
+          </a:xfrm>
+          <a:prstGeom prst="rect">
+            <a:avLst/>
+          </a:prstGeom>
+          <a:noFill/>
+        </p:spPr>
+        <p:txBody>
+          <a:bodyPr wrap="none">
+            <a:spAutoFit/>
+          </a:bodyPr>
+          <a:lstStyle/>
+          <a:p>
+            <a:pPr algn="l"/>
+            <a:r>
+              <a:rPr sz="750">
+                <a:solidFill>
+                  <a:srgbClr val="78808C"/>
+                </a:solidFill>
+                <a:latin typeface="Consolas"/>
+              </a:rPr>
               <a:t>VA05  ·  INHALT</a:t>
             </a:r>
           </a:p>
@@ -6895,7 +10418,7 @@
                 </a:solidFill>
                 <a:latin typeface="Arial"/>
               </a:rPr>
-              <a:t>Reflexionsfragen</a:t>
+              <a:t>Servicequalität: was der Kunde bewertet</a:t>
             </a:r>
           </a:p>
         </p:txBody>
@@ -6917,10 +10440,48 @@
           <a:noFill/>
         </p:spPr>
         <p:txBody>
-          <a:bodyPr wrap="square" anchor="ctr">
+          <a:bodyPr wrap="square">
             <a:spAutoFit/>
           </a:bodyPr>
           <a:lstStyle/>
+          <a:p>
+            <a:pPr marL="177800" indent="-177800">
+              <a:spcBef>
+                <a:spcPts val="600"/>
+              </a:spcBef>
+              <a:spcAft>
+                <a:spcPts val="200"/>
+              </a:spcAft>
+            </a:pPr>
+            <a:r>
+              <a:rPr sz="1200" i="1">
+                <a:solidFill>
+                  <a:srgbClr val="3D5466"/>
+                </a:solidFill>
+                <a:latin typeface="Arial"/>
+              </a:rPr>
+              <a:t>→  Zuverlässigkeit ist die wichtigste Servicedimension – Kunden reagieren auf eingehaltene Zusagen sensibler als auf jeden anderen Qualitätsindikator (Parasuraman et al., 1988).</a:t>
+            </a:r>
+          </a:p>
+          <a:p>
+            <a:pPr>
+              <a:spcBef>
+                <a:spcPts val="1000"/>
+              </a:spcBef>
+              <a:spcAft>
+                <a:spcPts val="200"/>
+              </a:spcAft>
+            </a:pPr>
+            <a:r>
+              <a:rPr sz="800" b="1">
+                <a:solidFill>
+                  <a:srgbClr val="78808C"/>
+                </a:solidFill>
+                <a:latin typeface="Consolas"/>
+              </a:rPr>
+              <a:t>VIER SERVQUAL-DIMENSIONEN FÜR DEN INNENDIENST</a:t>
+            </a:r>
+          </a:p>
           <a:p>
             <a:pPr marL="190500" indent="-190500">
               <a:spcBef>
@@ -6937,7 +10498,7 @@
                 </a:solidFill>
                 <a:latin typeface="Arial"/>
               </a:rPr>
-              <a:t>▸  Wann haben Sie zuletzt zuerst die Sache erklärt, obwohl die Beziehungsebene gestört war – was wäre besser gewesen?</a:t>
+              <a:t>▸  Zuverlässigkeit – Zusagen einhalten; was vereinbart ist, passiert.</a:t>
             </a:r>
           </a:p>
           <a:p>
@@ -6956,7 +10517,7 @@
                 </a:solidFill>
                 <a:latin typeface="Arial"/>
               </a:rPr>
-              <a:t>▸  Welche Ihrer Standardformulierungen klingen eher abweisend (z. B. „nicht zuständig") – wie ginge es freundlicher?</a:t>
+              <a:t>▸  Reaktionsfähigkeit – schnell erreichbar sein, zeitnah zurückrufen und antworten.</a:t>
             </a:r>
           </a:p>
           <a:p>
@@ -6975,7 +10536,26 @@
                 </a:solidFill>
                 <a:latin typeface="Arial"/>
               </a:rPr>
-              <a:t>▸  An welcher SERVQUAL-Dimension (Zuverlässigkeit, Reaktionsfähigkeit, Kompetenz, Einfühlung) wollen Sie persönlich arbeiten?</a:t>
+              <a:t>▸  Leistungskompetenz – fachlich sicher und verständlich Auskunft geben.</a:t>
+            </a:r>
+          </a:p>
+          <a:p>
+            <a:pPr marL="190500" indent="-190500">
+              <a:spcBef>
+                <a:spcPts val="400"/>
+              </a:spcBef>
+              <a:spcAft>
+                <a:spcPts val="200"/>
+              </a:spcAft>
+            </a:pPr>
+            <a:r>
+              <a:rPr sz="1300">
+                <a:solidFill>
+                  <a:srgbClr val="3D5466"/>
+                </a:solidFill>
+                <a:latin typeface="Arial"/>
+              </a:rPr>
+              <a:t>▸  Einfühlung – individuell auf das Anliegen eingehen, zuhören.</a:t>
             </a:r>
           </a:p>
         </p:txBody>

</xml_diff>